<commit_message>
Enhance presentation brightness and typography readability across all 10 slides
</commit_message>
<xml_diff>
--- a/TenderPulse_AI_Presentation.pptx
+++ b/TenderPulse_AI_Presentation.pptx
@@ -11377,6 +11377,9 @@
                 <a:spcPts val="0"/>
               </a:spcAft>
               <a:buNone/>
+              <a:defRPr>
+                <a:solidFill/>
+              </a:defRPr>
             </a:pPr>
             <a:r>
               <a:rPr b="1" i="0" lang="en-US" sz="1300" u="none" cap="none" strike="noStrike">
@@ -11427,11 +11430,14 @@
                 <a:spcPts val="0"/>
               </a:spcAft>
               <a:buNone/>
+              <a:defRPr>
+                <a:solidFill/>
+              </a:defRPr>
             </a:pPr>
             <a:r>
               <a:rPr b="0" i="0" lang="en-US" sz="1100" u="none" cap="none" strike="noStrike">
                 <a:solidFill>
-                  <a:srgbClr val="757068"/>
+                  <a:srgbClr val="FFFFFF"/>
                 </a:solidFill>
                 <a:latin typeface="Space Grotesk"/>
                 <a:ea typeface="Space Grotesk"/>
@@ -11510,6 +11516,9 @@
                 <a:spcPts val="0"/>
               </a:spcAft>
               <a:buNone/>
+              <a:defRPr>
+                <a:solidFill/>
+              </a:defRPr>
             </a:pPr>
             <a:r>
               <a:rPr b="1" i="0" lang="en-US" sz="1100" u="none" cap="none" strike="noStrike">
@@ -11560,11 +11569,14 @@
                 <a:spcPts val="0"/>
               </a:spcAft>
               <a:buNone/>
+              <a:defRPr>
+                <a:solidFill/>
+              </a:defRPr>
             </a:pPr>
             <a:r>
               <a:rPr b="0" i="0" lang="en-US" sz="900" u="none" cap="none" strike="noStrike">
                 <a:solidFill>
-                  <a:srgbClr val="757068"/>
+                  <a:srgbClr val="E1E6F0"/>
                 </a:solidFill>
                 <a:latin typeface="JetBrains Mono"/>
                 <a:ea typeface="JetBrains Mono"/>
@@ -11610,6 +11622,9 @@
                 <a:spcPts val="0"/>
               </a:spcAft>
               <a:buNone/>
+              <a:defRPr>
+                <a:solidFill/>
+              </a:defRPr>
             </a:pPr>
             <a:r>
               <a:rPr b="1" i="0" lang="en-US" sz="950" u="none" cap="none" strike="noStrike">
@@ -11663,9 +11678,18 @@
                 <a:spcPts val="0"/>
               </a:spcAft>
               <a:buNone/>
-              <a:defRPr sz="4000" b="1"/>
+              <a:defRPr sz="4400" b="1">
+                <a:solidFill>
+                  <a:srgbClr val="FFFFFF"/>
+                </a:solidFill>
+              </a:defRPr>
             </a:pPr>
             <a:r>
+              <a:rPr sz="4400" b="1">
+                <a:solidFill>
+                  <a:srgbClr val="FFFFFF"/>
+                </a:solidFill>
+              </a:rPr>
               <a:t>TenderPulse AI</a:t>
             </a:r>
             <a:endParaRPr/>
@@ -11708,9 +11732,18 @@
                 <a:spcPts val="0"/>
               </a:spcAft>
               <a:buNone/>
-              <a:defRPr sz="1800"/>
+              <a:defRPr sz="1900" b="0">
+                <a:solidFill>
+                  <a:srgbClr val="FFD778"/>
+                </a:solidFill>
+              </a:defRPr>
             </a:pPr>
             <a:r>
+              <a:rPr sz="1900" b="0">
+                <a:solidFill>
+                  <a:srgbClr val="FFD778"/>
+                </a:solidFill>
+              </a:rPr>
               <a:t>Autonomous Technical Bid Compliance Verification &amp; Procurement Decision Engine for CPCL / MoPNG</a:t>
             </a:r>
             <a:endParaRPr/>
@@ -11750,11 +11783,14 @@
                 <a:spcPts val="0"/>
               </a:spcAft>
               <a:buNone/>
+              <a:defRPr>
+                <a:solidFill/>
+              </a:defRPr>
             </a:pPr>
             <a:r>
               <a:rPr b="1" i="0" lang="en-US" sz="950" u="none" cap="none" strike="noStrike">
                 <a:solidFill>
-                  <a:srgbClr val="757068"/>
+                  <a:srgbClr val="F5B937"/>
                 </a:solidFill>
                 <a:latin typeface="JetBrains Mono"/>
                 <a:ea typeface="JetBrains Mono"/>
@@ -11800,9 +11836,18 @@
                 <a:spcPts val="0"/>
               </a:spcAft>
               <a:buNone/>
-              <a:defRPr sz="1600" b="1"/>
+              <a:defRPr sz="1700" b="1">
+                <a:solidFill>
+                  <a:srgbClr val="FFFFFF"/>
+                </a:solidFill>
+              </a:defRPr>
             </a:pPr>
             <a:r>
+              <a:rPr sz="1700" b="1">
+                <a:solidFill>
+                  <a:srgbClr val="FFFFFF"/>
+                </a:solidFill>
+              </a:rPr>
               <a:t>TeAm AsPirE</a:t>
             </a:r>
             <a:endParaRPr/>
@@ -11842,11 +11887,14 @@
                 <a:spcPts val="0"/>
               </a:spcAft>
               <a:buNone/>
+              <a:defRPr>
+                <a:solidFill/>
+              </a:defRPr>
             </a:pPr>
             <a:r>
               <a:rPr b="1" i="0" lang="en-US" sz="950" u="none" cap="none" strike="noStrike">
                 <a:solidFill>
-                  <a:srgbClr val="757068"/>
+                  <a:srgbClr val="F5B937"/>
                 </a:solidFill>
                 <a:latin typeface="JetBrains Mono"/>
                 <a:ea typeface="JetBrains Mono"/>
@@ -11892,9 +11940,18 @@
                 <a:spcPts val="0"/>
               </a:spcAft>
               <a:buNone/>
-              <a:defRPr sz="1600" b="1"/>
+              <a:defRPr sz="1700" b="1">
+                <a:solidFill>
+                  <a:srgbClr val="FFFFFF"/>
+                </a:solidFill>
+              </a:defRPr>
             </a:pPr>
             <a:r>
+              <a:rPr sz="1700" b="1">
+                <a:solidFill>
+                  <a:srgbClr val="FFFFFF"/>
+                </a:solidFill>
+              </a:rPr>
               <a:t>PS-04 · AI Decision Engine for Business Data</a:t>
             </a:r>
             <a:endParaRPr/>
@@ -11934,11 +11991,14 @@
                 <a:spcPts val="0"/>
               </a:spcAft>
               <a:buNone/>
+              <a:defRPr>
+                <a:solidFill/>
+              </a:defRPr>
             </a:pPr>
             <a:r>
               <a:rPr b="1" i="0" lang="en-US" sz="950" u="none" cap="none" strike="noStrike">
                 <a:solidFill>
-                  <a:srgbClr val="757068"/>
+                  <a:srgbClr val="F5B937"/>
                 </a:solidFill>
                 <a:latin typeface="JetBrains Mono"/>
                 <a:ea typeface="JetBrains Mono"/>
@@ -11984,9 +12044,18 @@
                 <a:spcPts val="0"/>
               </a:spcAft>
               <a:buNone/>
-              <a:defRPr sz="1600" b="1"/>
+              <a:defRPr sz="1700" b="1">
+                <a:solidFill>
+                  <a:srgbClr val="FFFFFF"/>
+                </a:solidFill>
+              </a:defRPr>
             </a:pPr>
             <a:r>
+              <a:rPr sz="1700" b="1">
+                <a:solidFill>
+                  <a:srgbClr val="FFFFFF"/>
+                </a:solidFill>
+              </a:rPr>
               <a:t>Darshan S (Team Lead)</a:t>
             </a:r>
             <a:endParaRPr/>
@@ -12078,6 +12147,9 @@
                 <a:spcPts val="0"/>
               </a:spcAft>
               <a:buNone/>
+              <a:defRPr>
+                <a:solidFill/>
+              </a:defRPr>
             </a:pPr>
             <a:r>
               <a:rPr b="1" i="0" lang="en-US" sz="1300">
@@ -12128,11 +12200,14 @@
                 <a:spcPts val="0"/>
               </a:spcAft>
               <a:buNone/>
+              <a:defRPr>
+                <a:solidFill/>
+              </a:defRPr>
             </a:pPr>
             <a:r>
               <a:rPr b="0" i="0" lang="en-US" sz="1100">
                 <a:solidFill>
-                  <a:srgbClr val="757068"/>
+                  <a:srgbClr val="F8FAFC"/>
                 </a:solidFill>
                 <a:latin typeface="Space Grotesk"/>
                 <a:ea typeface="Space Grotesk"/>
@@ -12211,6 +12286,9 @@
                 <a:spcPts val="0"/>
               </a:spcAft>
               <a:buNone/>
+              <a:defRPr>
+                <a:solidFill/>
+              </a:defRPr>
             </a:pPr>
             <a:r>
               <a:rPr b="1" i="0" lang="en-US" sz="1100">
@@ -12261,11 +12339,14 @@
                 <a:spcPts val="0"/>
               </a:spcAft>
               <a:buNone/>
+              <a:defRPr>
+                <a:solidFill/>
+              </a:defRPr>
             </a:pPr>
             <a:r>
               <a:rPr b="0" i="0" lang="en-US" sz="900">
                 <a:solidFill>
-                  <a:srgbClr val="757068"/>
+                  <a:srgbClr val="E1E6F0"/>
                 </a:solidFill>
                 <a:latin typeface="JetBrains Mono"/>
                 <a:ea typeface="JetBrains Mono"/>
@@ -12311,9 +12392,18 @@
                 <a:spcPts val="0"/>
               </a:spcAft>
               <a:buNone/>
-              <a:defRPr sz="1300" b="1"/>
+              <a:defRPr sz="1400" b="1">
+                <a:solidFill>
+                  <a:srgbClr val="F5B937"/>
+                </a:solidFill>
+              </a:defRPr>
             </a:pPr>
             <a:r>
+              <a:rPr sz="1400" b="1">
+                <a:solidFill>
+                  <a:srgbClr val="F5B937"/>
+                </a:solidFill>
+              </a:rPr>
               <a:t>TeAm AsPirE · PS-04 (AI Decision Engine for Business Data)</a:t>
             </a:r>
             <a:endParaRPr/>
@@ -12353,17 +12443,39 @@
                 <a:spcPts val="0"/>
               </a:spcAft>
               <a:buNone/>
-              <a:defRPr sz="4000" b="1"/>
+              <a:defRPr sz="4200" b="1">
+                <a:solidFill>
+                  <a:srgbClr val="FFFFFF"/>
+                </a:solidFill>
+              </a:defRPr>
             </a:pPr>
             <a:r>
+              <a:rPr sz="4200" b="1">
+                <a:solidFill>
+                  <a:srgbClr val="FFFFFF"/>
+                </a:solidFill>
+              </a:rPr>
               <a:t>Thank you.</a:t>
-            </a:r>
-            <a:br/>
-            <a:r>
-              <a:t>TenderPulse AI</a:t>
             </a:r>
             <a:endParaRPr/>
           </a:p>
+          <a:p>
+            <a:pPr>
+              <a:defRPr sz="4200" b="1">
+                <a:solidFill>
+                  <a:srgbClr val="FFFFFF"/>
+                </a:solidFill>
+              </a:defRPr>
+            </a:pPr>
+            <a:r>
+              <a:rPr sz="4200" b="1">
+                <a:solidFill>
+                  <a:srgbClr val="FFFFFF"/>
+                </a:solidFill>
+              </a:rPr>
+              <a:t>TenderPulse AI</a:t>
+            </a:r>
+          </a:p>
         </p:txBody>
       </p:sp>
       <p:sp>
@@ -12399,9 +12511,18 @@
                 <a:spcPts val="0"/>
               </a:spcAft>
               <a:buNone/>
-              <a:defRPr sz="1100" b="1"/>
+              <a:defRPr sz="1200" b="1">
+                <a:solidFill>
+                  <a:srgbClr val="F5B937"/>
+                </a:solidFill>
+              </a:defRPr>
             </a:pPr>
             <a:r>
+              <a:rPr sz="1200" b="1">
+                <a:solidFill>
+                  <a:srgbClr val="F5B937"/>
+                </a:solidFill>
+              </a:rPr>
               <a:t>PROJECT DELIVERABLES &amp; LIVE DEPLOYMENT</a:t>
             </a:r>
             <a:endParaRPr/>
@@ -12441,9 +12562,18 @@
                 <a:spcPts val="0"/>
               </a:spcAft>
               <a:buNone/>
-              <a:defRPr sz="1300"/>
+              <a:defRPr sz="1400">
+                <a:solidFill>
+                  <a:srgbClr val="FFD778"/>
+                </a:solidFill>
+              </a:defRPr>
             </a:pPr>
             <a:r>
+              <a:rPr sz="1400">
+                <a:solidFill>
+                  <a:srgbClr val="FFD778"/>
+                </a:solidFill>
+              </a:rPr>
               <a:t>Live App: https://ai-build-hackathon.onrender.com/  |  Repo: https://github.com/darshan-s-44/AI_build_hackathon</a:t>
             </a:r>
             <a:endParaRPr/>
@@ -12535,6 +12665,9 @@
                 <a:spcPts val="0"/>
               </a:spcAft>
               <a:buNone/>
+              <a:defRPr>
+                <a:solidFill/>
+              </a:defRPr>
             </a:pPr>
             <a:r>
               <a:rPr b="1" i="0" lang="en-US" sz="1300" u="none" cap="none" strike="noStrike">
@@ -12585,9 +12718,18 @@
                 <a:spcPts val="0"/>
               </a:spcAft>
               <a:buNone/>
-              <a:defRPr sz="1200"/>
+              <a:defRPr sz="1300">
+                <a:solidFill>
+                  <a:srgbClr val="E1E6F0"/>
+                </a:solidFill>
+              </a:defRPr>
             </a:pPr>
             <a:r>
+              <a:rPr sz="1300">
+                <a:solidFill>
+                  <a:srgbClr val="E1E6F0"/>
+                </a:solidFill>
+              </a:rPr>
               <a:t>02 · Architecture</a:t>
             </a:r>
             <a:endParaRPr/>
@@ -12660,6 +12802,9 @@
                 <a:spcPts val="0"/>
               </a:spcAft>
               <a:buNone/>
+              <a:defRPr>
+                <a:solidFill/>
+              </a:defRPr>
             </a:pPr>
             <a:r>
               <a:rPr b="1" i="0" lang="en-US" sz="1100" u="none" cap="none" strike="noStrike">
@@ -12710,11 +12855,14 @@
                 <a:spcPts val="0"/>
               </a:spcAft>
               <a:buNone/>
+              <a:defRPr>
+                <a:solidFill/>
+              </a:defRPr>
             </a:pPr>
             <a:r>
               <a:rPr b="0" i="0" lang="en-US" sz="900" u="none" cap="none" strike="noStrike">
                 <a:solidFill>
-                  <a:srgbClr val="757068"/>
+                  <a:srgbClr val="E1E6F0"/>
                 </a:solidFill>
                 <a:latin typeface="JetBrains Mono"/>
                 <a:ea typeface="JetBrains Mono"/>
@@ -12819,9 +12967,18 @@
                 <a:spcPts val="0"/>
               </a:spcAft>
               <a:buNone/>
-              <a:defRPr sz="1000" b="1"/>
+              <a:defRPr sz="1100" b="1">
+                <a:solidFill>
+                  <a:srgbClr val="141414"/>
+                </a:solidFill>
+              </a:defRPr>
             </a:pPr>
             <a:r>
+              <a:rPr sz="1100" b="1">
+                <a:solidFill>
+                  <a:srgbClr val="141414"/>
+                </a:solidFill>
+              </a:rPr>
               <a:t>CORE ARCHITECTURE</a:t>
             </a:r>
             <a:endParaRPr/>
@@ -12861,9 +13018,18 @@
                 <a:spcPts val="0"/>
               </a:spcAft>
               <a:buNone/>
-              <a:defRPr sz="1100" b="1"/>
+              <a:defRPr sz="1200" b="1">
+                <a:solidFill>
+                  <a:srgbClr val="F5B937"/>
+                </a:solidFill>
+              </a:defRPr>
             </a:pPr>
             <a:r>
+              <a:rPr sz="1200" b="1">
+                <a:solidFill>
+                  <a:srgbClr val="F5B937"/>
+                </a:solidFill>
+              </a:rPr>
               <a:t>SYSTEM ARCHITECTURE</a:t>
             </a:r>
             <a:endParaRPr/>
@@ -12906,9 +13072,18 @@
                 <a:spcPts val="0"/>
               </a:spcAft>
               <a:buNone/>
-              <a:defRPr sz="2800" b="1"/>
+              <a:defRPr sz="2800" b="1">
+                <a:solidFill>
+                  <a:srgbClr val="FFFFFF"/>
+                </a:solidFill>
+              </a:defRPr>
             </a:pPr>
             <a:r>
+              <a:rPr sz="2800" b="1">
+                <a:solidFill>
+                  <a:srgbClr val="FFFFFF"/>
+                </a:solidFill>
+              </a:rPr>
               <a:t>Dual-layer decision engine with self-correction guardrails</a:t>
             </a:r>
             <a:endParaRPr/>
@@ -13005,6 +13180,9 @@
                 <a:spcPts val="0"/>
               </a:spcAft>
               <a:buNone/>
+              <a:defRPr>
+                <a:solidFill/>
+              </a:defRPr>
             </a:pPr>
             <a:r>
               <a:rPr b="0" i="1" lang="en-US" sz="1700">
@@ -13055,9 +13233,18 @@
                 <a:spcPts val="0"/>
               </a:spcAft>
               <a:buNone/>
-              <a:defRPr sz="1400" b="1"/>
+              <a:defRPr sz="1400" b="1">
+                <a:solidFill>
+                  <a:srgbClr val="FFD778"/>
+                </a:solidFill>
+              </a:defRPr>
             </a:pPr>
             <a:r>
+              <a:rPr sz="1400" b="1">
+                <a:solidFill>
+                  <a:srgbClr val="FFD778"/>
+                </a:solidFill>
+              </a:rPr>
               <a:t>1. Ingest &amp; Layout Parse</a:t>
             </a:r>
             <a:endParaRPr/>
@@ -13100,9 +13287,18 @@
                 <a:spcPts val="0"/>
               </a:spcAft>
               <a:buNone/>
-              <a:defRPr sz="1200"/>
+              <a:defRPr sz="1200">
+                <a:solidFill>
+                  <a:srgbClr val="F8FAFC"/>
+                </a:solidFill>
+              </a:defRPr>
             </a:pPr>
             <a:r>
+              <a:rPr sz="1200">
+                <a:solidFill>
+                  <a:srgbClr val="F8FAFC"/>
+                </a:solidFill>
+              </a:rPr>
               <a:t>PyMuPDF normalizes multi-page unstructured PDF dossiers and CA tables.</a:t>
             </a:r>
             <a:endParaRPr/>
@@ -13199,6 +13395,9 @@
                 <a:spcPts val="0"/>
               </a:spcAft>
               <a:buNone/>
+              <a:defRPr>
+                <a:solidFill/>
+              </a:defRPr>
             </a:pPr>
             <a:r>
               <a:rPr b="0" i="1" lang="en-US" sz="1700">
@@ -13249,9 +13448,18 @@
                 <a:spcPts val="0"/>
               </a:spcAft>
               <a:buNone/>
-              <a:defRPr sz="1400" b="1"/>
+              <a:defRPr sz="1400" b="1">
+                <a:solidFill>
+                  <a:srgbClr val="FFD778"/>
+                </a:solidFill>
+              </a:defRPr>
             </a:pPr>
             <a:r>
+              <a:rPr sz="1400" b="1">
+                <a:solidFill>
+                  <a:srgbClr val="FFD778"/>
+                </a:solidFill>
+              </a:rPr>
               <a:t>2. Deterministic Solvers</a:t>
             </a:r>
             <a:endParaRPr/>
@@ -13294,9 +13502,18 @@
                 <a:spcPts val="0"/>
               </a:spcAft>
               <a:buNone/>
-              <a:defRPr sz="1200"/>
+              <a:defRPr sz="1200">
+                <a:solidFill>
+                  <a:srgbClr val="F8FAFC"/>
+                </a:solidFill>
+              </a:defRPr>
             </a:pPr>
             <a:r>
+              <a:rPr sz="1200">
+                <a:solidFill>
+                  <a:srgbClr val="F8FAFC"/>
+                </a:solidFill>
+              </a:rPr>
               <a:t>Exact math, ISO expiry dates, Mod-36 GSTIN check, and EMD bank guarantee sums.</a:t>
             </a:r>
             <a:endParaRPr/>
@@ -13393,6 +13610,9 @@
                 <a:spcPts val="0"/>
               </a:spcAft>
               <a:buNone/>
+              <a:defRPr>
+                <a:solidFill/>
+              </a:defRPr>
             </a:pPr>
             <a:r>
               <a:rPr b="0" i="1" lang="en-US" sz="1700">
@@ -13443,9 +13663,18 @@
                 <a:spcPts val="0"/>
               </a:spcAft>
               <a:buNone/>
-              <a:defRPr sz="1400" b="1"/>
+              <a:defRPr sz="1400" b="1">
+                <a:solidFill>
+                  <a:srgbClr val="FFD778"/>
+                </a:solidFill>
+              </a:defRPr>
             </a:pPr>
             <a:r>
+              <a:rPr sz="1400" b="1">
+                <a:solidFill>
+                  <a:srgbClr val="FFD778"/>
+                </a:solidFill>
+              </a:rPr>
               <a:t>3. Semantic Agent</a:t>
             </a:r>
             <a:endParaRPr/>
@@ -13488,9 +13717,18 @@
                 <a:spcPts val="0"/>
               </a:spcAft>
               <a:buNone/>
-              <a:defRPr sz="1200"/>
+              <a:defRPr sz="1200">
+                <a:solidFill>
+                  <a:srgbClr val="F8FAFC"/>
+                </a:solidFill>
+              </a:defRPr>
             </a:pPr>
             <a:r>
+              <a:rPr sz="1200">
+                <a:solidFill>
+                  <a:srgbClr val="F8FAFC"/>
+                </a:solidFill>
+              </a:rPr>
               <a:t>Contextual scope-of-work matching, spec equivalence, and UDYAM MSE relief parsing.</a:t>
             </a:r>
             <a:endParaRPr/>
@@ -13587,6 +13825,9 @@
                 <a:spcPts val="0"/>
               </a:spcAft>
               <a:buNone/>
+              <a:defRPr>
+                <a:solidFill/>
+              </a:defRPr>
             </a:pPr>
             <a:r>
               <a:rPr b="0" i="1" lang="en-US" sz="1700">
@@ -13637,9 +13878,18 @@
                 <a:spcPts val="0"/>
               </a:spcAft>
               <a:buNone/>
-              <a:defRPr sz="1400" b="1"/>
+              <a:defRPr sz="1400" b="1">
+                <a:solidFill>
+                  <a:srgbClr val="FFD778"/>
+                </a:solidFill>
+              </a:defRPr>
             </a:pPr>
             <a:r>
+              <a:rPr sz="1400" b="1">
+                <a:solidFill>
+                  <a:srgbClr val="FFD778"/>
+                </a:solidFill>
+              </a:rPr>
               <a:t>4. Reflection Guardrail</a:t>
             </a:r>
             <a:endParaRPr/>
@@ -13682,9 +13932,18 @@
                 <a:spcPts val="0"/>
               </a:spcAft>
               <a:buNone/>
-              <a:defRPr sz="1200"/>
+              <a:defRPr sz="1200">
+                <a:solidFill>
+                  <a:srgbClr val="F8FAFC"/>
+                </a:solidFill>
+              </a:defRPr>
             </a:pPr>
             <a:r>
+              <a:rPr sz="1200">
+                <a:solidFill>
+                  <a:srgbClr val="F8FAFC"/>
+                </a:solidFill>
+              </a:rPr>
               <a:t>Automated consistency checker eliminates hallucinations &amp; false positives.</a:t>
             </a:r>
             <a:endParaRPr/>
@@ -13781,6 +14040,9 @@
                 <a:spcPts val="0"/>
               </a:spcAft>
               <a:buNone/>
+              <a:defRPr>
+                <a:solidFill/>
+              </a:defRPr>
             </a:pPr>
             <a:r>
               <a:rPr b="0" i="1" lang="en-US" sz="1700">
@@ -13831,9 +14093,18 @@
                 <a:spcPts val="0"/>
               </a:spcAft>
               <a:buNone/>
-              <a:defRPr sz="1400" b="1"/>
+              <a:defRPr sz="1400" b="1">
+                <a:solidFill>
+                  <a:srgbClr val="FFD778"/>
+                </a:solidFill>
+              </a:defRPr>
             </a:pPr>
             <a:r>
+              <a:rPr sz="1400" b="1">
+                <a:solidFill>
+                  <a:srgbClr val="FFD778"/>
+                </a:solidFill>
+              </a:rPr>
               <a:t>5. Clause-Attribution Graph</a:t>
             </a:r>
             <a:endParaRPr/>
@@ -13876,9 +14147,18 @@
                 <a:spcPts val="0"/>
               </a:spcAft>
               <a:buNone/>
-              <a:defRPr sz="1200"/>
+              <a:defRPr sz="1200">
+                <a:solidFill>
+                  <a:srgbClr val="F8FAFC"/>
+                </a:solidFill>
+              </a:defRPr>
             </a:pPr>
             <a:r>
+              <a:rPr sz="1200">
+                <a:solidFill>
+                  <a:srgbClr val="F8FAFC"/>
+                </a:solidFill>
+              </a:rPr>
               <a:t>100% traceable link connecting verdicts to verbatim quotes and page numbers.</a:t>
             </a:r>
             <a:endParaRPr/>
@@ -13975,6 +14255,9 @@
                 <a:spcPts val="0"/>
               </a:spcAft>
               <a:buNone/>
+              <a:defRPr>
+                <a:solidFill/>
+              </a:defRPr>
             </a:pPr>
             <a:r>
               <a:rPr b="0" i="1" lang="en-US" sz="1700">
@@ -14025,9 +14308,18 @@
                 <a:spcPts val="0"/>
               </a:spcAft>
               <a:buNone/>
-              <a:defRPr sz="1400" b="1"/>
+              <a:defRPr sz="1400" b="1">
+                <a:solidFill>
+                  <a:srgbClr val="FFD778"/>
+                </a:solidFill>
+              </a:defRPr>
             </a:pPr>
             <a:r>
+              <a:rPr sz="1400" b="1">
+                <a:solidFill>
+                  <a:srgbClr val="FFD778"/>
+                </a:solidFill>
+              </a:rPr>
               <a:t>6. CVC Audit Scorecard</a:t>
             </a:r>
             <a:endParaRPr/>
@@ -14070,9 +14362,18 @@
                 <a:spcPts val="0"/>
               </a:spcAft>
               <a:buNone/>
-              <a:defRPr sz="1200"/>
+              <a:defRPr sz="1200">
+                <a:solidFill>
+                  <a:srgbClr val="F8FAFC"/>
+                </a:solidFill>
+              </a:defRPr>
             </a:pPr>
             <a:r>
+              <a:rPr sz="1200">
+                <a:solidFill>
+                  <a:srgbClr val="F8FAFC"/>
+                </a:solidFill>
+              </a:rPr>
               <a:t>PASS / CONDITIONAL / REJECT in 1.2s with downloadable vigilance audit PDF.</a:t>
             </a:r>
             <a:endParaRPr/>
@@ -14164,6 +14465,9 @@
                 <a:spcPts val="0"/>
               </a:spcAft>
               <a:buNone/>
+              <a:defRPr>
+                <a:solidFill/>
+              </a:defRPr>
             </a:pPr>
             <a:r>
               <a:rPr b="1" i="0" lang="en-US" sz="1300">
@@ -14214,9 +14518,18 @@
                 <a:spcPts val="0"/>
               </a:spcAft>
               <a:buNone/>
-              <a:defRPr sz="1200"/>
+              <a:defRPr sz="1300">
+                <a:solidFill>
+                  <a:srgbClr val="E1E6F0"/>
+                </a:solidFill>
+              </a:defRPr>
             </a:pPr>
             <a:r>
+              <a:rPr sz="1300">
+                <a:solidFill>
+                  <a:srgbClr val="E1E6F0"/>
+                </a:solidFill>
+              </a:rPr>
               <a:t>03 · Live Prototype</a:t>
             </a:r>
             <a:endParaRPr/>
@@ -14289,6 +14602,9 @@
                 <a:spcPts val="0"/>
               </a:spcAft>
               <a:buNone/>
+              <a:defRPr>
+                <a:solidFill/>
+              </a:defRPr>
             </a:pPr>
             <a:r>
               <a:rPr b="1" i="0" lang="en-US" sz="1100">
@@ -14339,11 +14655,14 @@
                 <a:spcPts val="0"/>
               </a:spcAft>
               <a:buNone/>
+              <a:defRPr>
+                <a:solidFill/>
+              </a:defRPr>
             </a:pPr>
             <a:r>
               <a:rPr b="0" i="0" lang="en-US" sz="900">
                 <a:solidFill>
-                  <a:srgbClr val="757068"/>
+                  <a:srgbClr val="E1E6F0"/>
                 </a:solidFill>
                 <a:latin typeface="JetBrains Mono"/>
                 <a:ea typeface="JetBrains Mono"/>
@@ -14448,9 +14767,18 @@
                 <a:spcPts val="0"/>
               </a:spcAft>
               <a:buNone/>
-              <a:defRPr sz="1000" b="1"/>
+              <a:defRPr sz="1100" b="1">
+                <a:solidFill>
+                  <a:srgbClr val="141414"/>
+                </a:solidFill>
+              </a:defRPr>
             </a:pPr>
             <a:r>
+              <a:rPr sz="1100" b="1">
+                <a:solidFill>
+                  <a:srgbClr val="141414"/>
+                </a:solidFill>
+              </a:rPr>
               <a:t>WORKING PROTOTYPE</a:t>
             </a:r>
             <a:endParaRPr/>
@@ -14490,9 +14818,18 @@
                 <a:spcPts val="0"/>
               </a:spcAft>
               <a:buNone/>
-              <a:defRPr sz="1100" b="1"/>
+              <a:defRPr sz="1200" b="1">
+                <a:solidFill>
+                  <a:srgbClr val="F5B937"/>
+                </a:solidFill>
+              </a:defRPr>
             </a:pPr>
             <a:r>
+              <a:rPr sz="1200" b="1">
+                <a:solidFill>
+                  <a:srgbClr val="F5B937"/>
+                </a:solidFill>
+              </a:rPr>
               <a:t>LIVE WORKSPACE</a:t>
             </a:r>
             <a:endParaRPr/>
@@ -14535,9 +14872,18 @@
                 <a:spcPts val="0"/>
               </a:spcAft>
               <a:buNone/>
-              <a:defRPr sz="2800" b="1"/>
+              <a:defRPr sz="2800" b="1">
+                <a:solidFill>
+                  <a:srgbClr val="FFFFFF"/>
+                </a:solidFill>
+              </a:defRPr>
             </a:pPr>
             <a:r>
+              <a:rPr sz="2800" b="1">
+                <a:solidFill>
+                  <a:srgbClr val="FFFFFF"/>
+                </a:solidFill>
+              </a:rPr>
               <a:t>Three views. One defensible finding.</a:t>
             </a:r>
             <a:endParaRPr/>
@@ -14661,6 +15007,9 @@
                 <a:spcPts val="0"/>
               </a:spcAft>
               <a:buNone/>
+              <a:defRPr>
+                <a:solidFill/>
+              </a:defRPr>
             </a:pPr>
             <a:r>
               <a:rPr b="0" i="1" lang="en-US" sz="1700">
@@ -14711,9 +15060,18 @@
                 <a:spcPts val="0"/>
               </a:spcAft>
               <a:buNone/>
-              <a:defRPr sz="1400" b="1"/>
+              <a:defRPr sz="1400" b="1">
+                <a:solidFill>
+                  <a:srgbClr val="FFD778"/>
+                </a:solidFill>
+              </a:defRPr>
             </a:pPr>
             <a:r>
+              <a:rPr sz="1400" b="1">
+                <a:solidFill>
+                  <a:srgbClr val="FFD778"/>
+                </a:solidFill>
+              </a:rPr>
               <a:t>Review Queue (13 Bids)</a:t>
             </a:r>
             <a:endParaRPr/>
@@ -14756,9 +15114,18 @@
                 <a:spcPts val="0"/>
               </a:spcAft>
               <a:buNone/>
-              <a:defRPr sz="1200"/>
+              <a:defRPr sz="1200">
+                <a:solidFill>
+                  <a:srgbClr val="F8FAFC"/>
+                </a:solidFill>
+              </a:defRPr>
             </a:pPr>
             <a:r>
+              <a:rPr sz="1200">
+                <a:solidFill>
+                  <a:srgbClr val="F8FAFC"/>
+                </a:solidFill>
+              </a:rPr>
               <a:t>Side-by-side queue auditing 13 CPCL packages with live PASS, FAIL, &amp; CONDITIONAL tags.</a:t>
             </a:r>
             <a:endParaRPr/>
@@ -14855,6 +15222,9 @@
                 <a:spcPts val="0"/>
               </a:spcAft>
               <a:buNone/>
+              <a:defRPr>
+                <a:solidFill/>
+              </a:defRPr>
             </a:pPr>
             <a:r>
               <a:rPr b="0" i="1" lang="en-US" sz="1700">
@@ -14905,9 +15275,18 @@
                 <a:spcPts val="0"/>
               </a:spcAft>
               <a:buNone/>
-              <a:defRPr sz="1400" b="1"/>
+              <a:defRPr sz="1400" b="1">
+                <a:solidFill>
+                  <a:srgbClr val="FFD778"/>
+                </a:solidFill>
+              </a:defRPr>
             </a:pPr>
             <a:r>
+              <a:rPr sz="1400" b="1">
+                <a:solidFill>
+                  <a:srgbClr val="FFD778"/>
+                </a:solidFill>
+              </a:rPr>
               <a:t>Split-Screen Evidence</a:t>
             </a:r>
             <a:endParaRPr/>
@@ -14950,9 +15329,18 @@
                 <a:spcPts val="0"/>
               </a:spcAft>
               <a:buNone/>
-              <a:defRPr sz="1200"/>
+              <a:defRPr sz="1200">
+                <a:solidFill>
+                  <a:srgbClr val="F8FAFC"/>
+                </a:solidFill>
+              </a:defRPr>
             </a:pPr>
             <a:r>
+              <a:rPr sz="1200">
+                <a:solidFill>
+                  <a:srgbClr val="F8FAFC"/>
+                </a:solidFill>
+              </a:rPr>
               <a:t>PyMuPDF text stream highlighting CA balance sheets, ISO validity, and SBI bank guarantees.</a:t>
             </a:r>
             <a:endParaRPr/>
@@ -15049,6 +15437,9 @@
                 <a:spcPts val="0"/>
               </a:spcAft>
               <a:buNone/>
+              <a:defRPr>
+                <a:solidFill/>
+              </a:defRPr>
             </a:pPr>
             <a:r>
               <a:rPr b="0" i="1" lang="en-US" sz="1700">
@@ -15099,9 +15490,18 @@
                 <a:spcPts val="0"/>
               </a:spcAft>
               <a:buNone/>
-              <a:defRPr sz="1400" b="1"/>
+              <a:defRPr sz="1400" b="1">
+                <a:solidFill>
+                  <a:srgbClr val="FFD778"/>
+                </a:solidFill>
+              </a:defRPr>
             </a:pPr>
             <a:r>
+              <a:rPr sz="1400" b="1">
+                <a:solidFill>
+                  <a:srgbClr val="FFD778"/>
+                </a:solidFill>
+              </a:rPr>
               <a:t>Cloud Deployed &amp; Verified</a:t>
             </a:r>
             <a:endParaRPr/>
@@ -15144,9 +15544,18 @@
                 <a:spcPts val="0"/>
               </a:spcAft>
               <a:buNone/>
-              <a:defRPr sz="1200"/>
+              <a:defRPr sz="1200">
+                <a:solidFill>
+                  <a:srgbClr val="F8FAFC"/>
+                </a:solidFill>
+              </a:defRPr>
             </a:pPr>
             <a:r>
+              <a:rPr sz="1200">
+                <a:solidFill>
+                  <a:srgbClr val="F8FAFC"/>
+                </a:solidFill>
+              </a:rPr>
               <a:t>Live on Render (https://ai-build-hackathon.onrender.com) with 1-click PDF audit export.</a:t>
             </a:r>
             <a:endParaRPr/>
@@ -15238,6 +15647,9 @@
                 <a:spcPts val="0"/>
               </a:spcAft>
               <a:buNone/>
+              <a:defRPr>
+                <a:solidFill/>
+              </a:defRPr>
             </a:pPr>
             <a:r>
               <a:rPr b="1" i="0" lang="en-US" sz="1300">
@@ -15288,11 +15700,14 @@
                 <a:spcPts val="0"/>
               </a:spcAft>
               <a:buNone/>
+              <a:defRPr>
+                <a:solidFill/>
+              </a:defRPr>
             </a:pPr>
             <a:r>
               <a:rPr b="0" i="0" lang="en-US" sz="1100">
                 <a:solidFill>
-                  <a:srgbClr val="757068"/>
+                  <a:srgbClr val="E1E6F0"/>
                 </a:solidFill>
                 <a:latin typeface="Space Grotesk"/>
                 <a:ea typeface="Space Grotesk"/>
@@ -15371,6 +15786,9 @@
                 <a:spcPts val="0"/>
               </a:spcAft>
               <a:buNone/>
+              <a:defRPr>
+                <a:solidFill/>
+              </a:defRPr>
             </a:pPr>
             <a:r>
               <a:rPr b="1" i="0" lang="en-US" sz="1100">
@@ -15421,11 +15839,14 @@
                 <a:spcPts val="0"/>
               </a:spcAft>
               <a:buNone/>
+              <a:defRPr>
+                <a:solidFill/>
+              </a:defRPr>
             </a:pPr>
             <a:r>
               <a:rPr b="0" i="0" lang="en-US" sz="900">
                 <a:solidFill>
-                  <a:srgbClr val="757068"/>
+                  <a:srgbClr val="E1E6F0"/>
                 </a:solidFill>
                 <a:latin typeface="JetBrains Mono"/>
                 <a:ea typeface="JetBrains Mono"/>
@@ -15471,6 +15892,9 @@
                 <a:spcPts val="0"/>
               </a:spcAft>
               <a:buNone/>
+              <a:defRPr>
+                <a:solidFill/>
+              </a:defRPr>
             </a:pPr>
             <a:r>
               <a:rPr b="1" i="0" lang="en-US" sz="950">
@@ -15524,6 +15948,9 @@
                 <a:spcPts val="0"/>
               </a:spcAft>
               <a:buNone/>
+              <a:defRPr>
+                <a:solidFill/>
+              </a:defRPr>
             </a:pPr>
             <a:r>
               <a:rPr b="0" i="0" lang="en-US" sz="5000">
@@ -15645,6 +16072,9 @@
                 <a:spcPts val="0"/>
               </a:spcAft>
               <a:buNone/>
+              <a:defRPr>
+                <a:solidFill/>
+              </a:defRPr>
             </a:pPr>
             <a:r>
               <a:rPr b="1" i="0" lang="en-US" sz="950">
@@ -15698,14 +16128,19 @@
                 <a:spcPts val="0"/>
               </a:spcAft>
               <a:buNone/>
-              <a:defRPr sz="1300"/>
+              <a:defRPr sz="1300" b="0">
+                <a:solidFill>
+                  <a:srgbClr val="F8FAFC"/>
+                </a:solidFill>
+              </a:defRPr>
             </a:pPr>
             <a:r>
+              <a:rPr sz="1300" b="0">
+                <a:solidFill>
+                  <a:srgbClr val="F8FAFC"/>
+                </a:solidFill>
+              </a:rPr>
               <a:t>PS-04 · AI Decision Engine for Business Data</a:t>
-            </a:r>
-            <a:br/>
-            <a:r>
-              <a:t>High-Stakes Technical Bid Verification Overhead in Public Procurement (CPCL / MoPNG)</a:t>
             </a:r>
             <a:endParaRPr/>
           </a:p>
@@ -15721,7 +16156,20 @@
                 <a:spcPts val="0"/>
               </a:spcAft>
               <a:buNone/>
+              <a:defRPr sz="1300" b="0">
+                <a:solidFill>
+                  <a:srgbClr val="F8FAFC"/>
+                </a:solidFill>
+              </a:defRPr>
             </a:pPr>
+            <a:r>
+              <a:rPr sz="1300" b="0">
+                <a:solidFill>
+                  <a:srgbClr val="F8FAFC"/>
+                </a:solidFill>
+              </a:rPr>
+              <a:t>High-Stakes Technical Bid Verification Overhead in Public Procurement (CPCL / MoPNG)</a:t>
+            </a:r>
             <a:endParaRPr/>
           </a:p>
         </p:txBody>
@@ -15818,6 +16266,9 @@
                 <a:spcPts val="0"/>
               </a:spcAft>
               <a:buNone/>
+              <a:defRPr>
+                <a:solidFill/>
+              </a:defRPr>
             </a:pPr>
             <a:r>
               <a:rPr b="1" i="0" lang="en-US" sz="950">
@@ -15871,9 +16322,18 @@
                 <a:spcPts val="0"/>
               </a:spcAft>
               <a:buNone/>
-              <a:defRPr sz="1200"/>
+              <a:defRPr sz="1200">
+                <a:solidFill>
+                  <a:srgbClr val="F8FAFC"/>
+                </a:solidFill>
+              </a:defRPr>
             </a:pPr>
             <a:r>
+              <a:rPr sz="1200">
+                <a:solidFill>
+                  <a:srgbClr val="F8FAFC"/>
+                </a:solidFill>
+              </a:rPr>
               <a:t>Technical Evaluation Committees, Vigilance Officers (CVC), and GeM Procurement Executives across CPSEs (CPCL, Indian Oil, ONGC) handling refinery &amp; infrastructure tenders.</a:t>
             </a:r>
             <a:endParaRPr/>
@@ -15972,6 +16432,9 @@
                 <a:spcPts val="0"/>
               </a:spcAft>
               <a:buNone/>
+              <a:defRPr>
+                <a:solidFill/>
+              </a:defRPr>
             </a:pPr>
             <a:r>
               <a:rPr b="1" i="0" lang="en-US" sz="950">
@@ -16025,24 +16488,72 @@
                 <a:spcPts val="0"/>
               </a:spcAft>
               <a:buNone/>
-              <a:defRPr sz="1200"/>
+              <a:defRPr sz="1200">
+                <a:solidFill>
+                  <a:srgbClr val="F8FAFC"/>
+                </a:solidFill>
+              </a:defRPr>
             </a:pPr>
             <a:r>
+              <a:rPr sz="1200">
+                <a:solidFill>
+                  <a:srgbClr val="F8FAFC"/>
+                </a:solidFill>
+              </a:rPr>
               <a:t>• 3 to 5 business days spent manually auditing 100+ pages of unstructured scans per vendor.</a:t>
             </a:r>
-            <a:br/>
+            <a:endParaRPr/>
+          </a:p>
+          <a:p>
+            <a:pPr>
+              <a:defRPr sz="1200">
+                <a:solidFill>
+                  <a:srgbClr val="F8FAFC"/>
+                </a:solidFill>
+              </a:defRPr>
+            </a:pPr>
             <a:r>
+              <a:rPr sz="1200">
+                <a:solidFill>
+                  <a:srgbClr val="F8FAFC"/>
+                </a:solidFill>
+              </a:rPr>
               <a:t>• 40%+ disqualification rate due to non-material clerical oversights, unfairly excluding compliant Indian MSMEs.</a:t>
             </a:r>
-            <a:br/>
+          </a:p>
+          <a:p>
+            <a:pPr>
+              <a:defRPr sz="1200">
+                <a:solidFill>
+                  <a:srgbClr val="F8FAFC"/>
+                </a:solidFill>
+              </a:defRPr>
+            </a:pPr>
             <a:r>
+              <a:rPr sz="1200">
+                <a:solidFill>
+                  <a:srgbClr val="F8FAFC"/>
+                </a:solidFill>
+              </a:rPr>
               <a:t>• Severe vigilance &amp; legal scrutiny under CVC guidelines from forged GSTINs, expired ISOs, or shell fronting.</a:t>
             </a:r>
-            <a:br/>
+          </a:p>
+          <a:p>
+            <a:pPr>
+              <a:defRPr sz="1200">
+                <a:solidFill>
+                  <a:srgbClr val="F8FAFC"/>
+                </a:solidFill>
+              </a:defRPr>
+            </a:pPr>
             <a:r>
+              <a:rPr sz="1200">
+                <a:solidFill>
+                  <a:srgbClr val="F8FAFC"/>
+                </a:solidFill>
+              </a:rPr>
               <a:t>• Standard LLMs hallucinate financial figures and fail to provide clause-verifiable evidence chains.</a:t>
             </a:r>
-            <a:endParaRPr/>
           </a:p>
         </p:txBody>
       </p:sp>
@@ -16131,6 +16642,9 @@
                 <a:spcPts val="0"/>
               </a:spcAft>
               <a:buNone/>
+              <a:defRPr>
+                <a:solidFill/>
+              </a:defRPr>
             </a:pPr>
             <a:r>
               <a:rPr b="1" i="0" lang="en-US" sz="1300">
@@ -16181,11 +16695,14 @@
                 <a:spcPts val="0"/>
               </a:spcAft>
               <a:buNone/>
+              <a:defRPr>
+                <a:solidFill/>
+              </a:defRPr>
             </a:pPr>
             <a:r>
               <a:rPr b="0" i="0" lang="en-US" sz="1100">
                 <a:solidFill>
-                  <a:srgbClr val="757068"/>
+                  <a:srgbClr val="E1E6F0"/>
                 </a:solidFill>
                 <a:latin typeface="Space Grotesk"/>
                 <a:ea typeface="Space Grotesk"/>
@@ -16264,6 +16781,9 @@
                 <a:spcPts val="0"/>
               </a:spcAft>
               <a:buNone/>
+              <a:defRPr>
+                <a:solidFill/>
+              </a:defRPr>
             </a:pPr>
             <a:r>
               <a:rPr b="1" i="0" lang="en-US" sz="1100">
@@ -16314,11 +16834,14 @@
                 <a:spcPts val="0"/>
               </a:spcAft>
               <a:buNone/>
+              <a:defRPr>
+                <a:solidFill/>
+              </a:defRPr>
             </a:pPr>
             <a:r>
               <a:rPr b="0" i="0" lang="en-US" sz="900">
                 <a:solidFill>
-                  <a:srgbClr val="757068"/>
+                  <a:srgbClr val="E1E6F0"/>
                 </a:solidFill>
                 <a:latin typeface="JetBrains Mono"/>
                 <a:ea typeface="JetBrains Mono"/>
@@ -16364,6 +16887,9 @@
                 <a:spcPts val="0"/>
               </a:spcAft>
               <a:buNone/>
+              <a:defRPr>
+                <a:solidFill/>
+              </a:defRPr>
             </a:pPr>
             <a:r>
               <a:rPr b="1" i="0" lang="en-US" sz="950">
@@ -16417,6 +16943,9 @@
                 <a:spcPts val="0"/>
               </a:spcAft>
               <a:buNone/>
+              <a:defRPr>
+                <a:solidFill/>
+              </a:defRPr>
             </a:pPr>
             <a:r>
               <a:rPr b="0" i="0" lang="en-US" sz="5000">
@@ -16538,6 +17067,9 @@
                 <a:spcPts val="0"/>
               </a:spcAft>
               <a:buNone/>
+              <a:defRPr>
+                <a:solidFill/>
+              </a:defRPr>
             </a:pPr>
             <a:r>
               <a:rPr b="1" i="0" lang="en-US" sz="950">
@@ -16591,9 +17123,18 @@
                 <a:spcPts val="0"/>
               </a:spcAft>
               <a:buNone/>
-              <a:defRPr sz="1300"/>
+              <a:defRPr sz="1300">
+                <a:solidFill>
+                  <a:srgbClr val="F8FAFC"/>
+                </a:solidFill>
+              </a:defRPr>
             </a:pPr>
             <a:r>
+              <a:rPr sz="1300">
+                <a:solidFill>
+                  <a:srgbClr val="F8FAFC"/>
+                </a:solidFill>
+              </a:rPr>
               <a:t>TenderPulse AI is an autonomous, zero-hallucination AI decision engine that ingests scanned multi-page bid dossiers, validates them against official NIT criteria via dual-layer verification, and generates a vigilance-grade audit verdict in 1.2 seconds.</a:t>
             </a:r>
             <a:endParaRPr/>
@@ -16692,6 +17233,9 @@
                 <a:spcPts val="0"/>
               </a:spcAft>
               <a:buNone/>
+              <a:defRPr>
+                <a:solidFill/>
+              </a:defRPr>
             </a:pPr>
             <a:r>
               <a:rPr b="1" i="0" lang="en-US" sz="950">
@@ -16745,9 +17289,18 @@
                 <a:spcPts val="0"/>
               </a:spcAft>
               <a:buNone/>
-              <a:defRPr sz="1200"/>
+              <a:defRPr sz="1200">
+                <a:solidFill>
+                  <a:srgbClr val="F8FAFC"/>
+                </a:solidFill>
+              </a:defRPr>
             </a:pPr>
             <a:r>
+              <a:rPr sz="1200">
+                <a:solidFill>
+                  <a:srgbClr val="F8FAFC"/>
+                </a:solidFill>
+              </a:rPr>
               <a:t>The procurement officer selects or uploads a vendor's multi-page technical bid package (PDF) and clicks 'Audit Selected Dossier'.</a:t>
             </a:r>
             <a:endParaRPr/>
@@ -16846,6 +17399,9 @@
                 <a:spcPts val="0"/>
               </a:spcAft>
               <a:buNone/>
+              <a:defRPr>
+                <a:solidFill/>
+              </a:defRPr>
             </a:pPr>
             <a:r>
               <a:rPr b="1" i="0" lang="en-US" sz="950">
@@ -16899,9 +17455,18 @@
                 <a:spcPts val="0"/>
               </a:spcAft>
               <a:buNone/>
-              <a:defRPr sz="1200"/>
+              <a:defRPr sz="1200">
+                <a:solidFill>
+                  <a:srgbClr val="F8FAFC"/>
+                </a:solidFill>
+              </a:defRPr>
             </a:pPr>
             <a:r>
+              <a:rPr sz="1200">
+                <a:solidFill>
+                  <a:srgbClr val="F8FAFC"/>
+                </a:solidFill>
+              </a:rPr>
               <a:t>An instant, CVC-defensible compliance scorecard (PASS / CONDITIONAL / REJECT) with clause-level citations, reflection traces, and a one-click downloadable PDF audit report.</a:t>
             </a:r>
             <a:endParaRPr/>
@@ -16993,6 +17558,9 @@
                 <a:spcPts val="0"/>
               </a:spcAft>
               <a:buNone/>
+              <a:defRPr>
+                <a:solidFill/>
+              </a:defRPr>
             </a:pPr>
             <a:r>
               <a:rPr b="1" i="0" lang="en-US" sz="1300">
@@ -17043,11 +17611,14 @@
                 <a:spcPts val="0"/>
               </a:spcAft>
               <a:buNone/>
+              <a:defRPr>
+                <a:solidFill/>
+              </a:defRPr>
             </a:pPr>
             <a:r>
               <a:rPr b="0" i="0" lang="en-US" sz="1100">
                 <a:solidFill>
-                  <a:srgbClr val="757068"/>
+                  <a:srgbClr val="E1E6F0"/>
                 </a:solidFill>
                 <a:latin typeface="Space Grotesk"/>
                 <a:ea typeface="Space Grotesk"/>
@@ -17126,6 +17697,9 @@
                 <a:spcPts val="0"/>
               </a:spcAft>
               <a:buNone/>
+              <a:defRPr>
+                <a:solidFill/>
+              </a:defRPr>
             </a:pPr>
             <a:r>
               <a:rPr b="1" i="0" lang="en-US" sz="1100">
@@ -17176,11 +17750,14 @@
                 <a:spcPts val="0"/>
               </a:spcAft>
               <a:buNone/>
+              <a:defRPr>
+                <a:solidFill/>
+              </a:defRPr>
             </a:pPr>
             <a:r>
               <a:rPr b="0" i="0" lang="en-US" sz="900">
                 <a:solidFill>
-                  <a:srgbClr val="757068"/>
+                  <a:srgbClr val="E1E6F0"/>
                 </a:solidFill>
                 <a:latin typeface="JetBrains Mono"/>
                 <a:ea typeface="JetBrains Mono"/>
@@ -17226,6 +17803,9 @@
                 <a:spcPts val="0"/>
               </a:spcAft>
               <a:buNone/>
+              <a:defRPr>
+                <a:solidFill/>
+              </a:defRPr>
             </a:pPr>
             <a:r>
               <a:rPr b="1" i="0" lang="en-US" sz="950">
@@ -17279,6 +17859,9 @@
                 <a:spcPts val="0"/>
               </a:spcAft>
               <a:buNone/>
+              <a:defRPr>
+                <a:solidFill/>
+              </a:defRPr>
             </a:pPr>
             <a:r>
               <a:rPr b="0" i="0" lang="en-US" sz="5000">
@@ -17400,6 +17983,9 @@
                 <a:spcPts val="0"/>
               </a:spcAft>
               <a:buNone/>
+              <a:defRPr>
+                <a:solidFill/>
+              </a:defRPr>
             </a:pPr>
             <a:r>
               <a:rPr b="1" i="0" lang="en-US" sz="950">
@@ -17453,9 +18039,18 @@
                 <a:spcPts val="0"/>
               </a:spcAft>
               <a:buNone/>
-              <a:defRPr sz="1200"/>
+              <a:defRPr sz="1200">
+                <a:solidFill>
+                  <a:srgbClr val="F8FAFC"/>
+                </a:solidFill>
+              </a:defRPr>
             </a:pPr>
             <a:r>
+              <a:rPr sz="1200">
+                <a:solidFill>
+                  <a:srgbClr val="F8FAFC"/>
+                </a:solidFill>
+              </a:rPr>
               <a:t>Dual-layer hybrid stack: Deterministic constraint algorithms for statutory math/dates + LiteLLM / Semantic Agent for contextual scope matching, technical spec equivalence, and UDYAM MSE relief analysis.</a:t>
             </a:r>
             <a:endParaRPr/>
@@ -17554,6 +18149,9 @@
                 <a:spcPts val="0"/>
               </a:spcAft>
               <a:buNone/>
+              <a:defRPr>
+                <a:solidFill/>
+              </a:defRPr>
             </a:pPr>
             <a:r>
               <a:rPr b="1" i="0" lang="en-US" sz="950">
@@ -17607,9 +18205,18 @@
                 <a:spcPts val="0"/>
               </a:spcAft>
               <a:buNone/>
-              <a:defRPr sz="1200"/>
+              <a:defRPr sz="1200">
+                <a:solidFill>
+                  <a:srgbClr val="F8FAFC"/>
+                </a:solidFill>
+              </a:defRPr>
             </a:pPr>
             <a:r>
+              <a:rPr sz="1200">
+                <a:solidFill>
+                  <a:srgbClr val="F8FAFC"/>
+                </a:solidFill>
+              </a:rPr>
               <a:t>PyMuPDF (layout-normalized parsing), Python 3.11, Mod-36 GSTIN Validator, ReportLab (PDF audit generator), and Docker / Render cloud deployment.</a:t>
             </a:r>
             <a:endParaRPr/>
@@ -17708,6 +18315,9 @@
                 <a:spcPts val="0"/>
               </a:spcAft>
               <a:buNone/>
+              <a:defRPr>
+                <a:solidFill/>
+              </a:defRPr>
             </a:pPr>
             <a:r>
               <a:rPr b="1" i="0" lang="en-US" sz="950">
@@ -17761,9 +18371,18 @@
                 <a:spcPts val="0"/>
               </a:spcAft>
               <a:buNone/>
-              <a:defRPr sz="1200"/>
+              <a:defRPr sz="1200">
+                <a:solidFill>
+                  <a:srgbClr val="F8FAFC"/>
+                </a:solidFill>
+              </a:defRPr>
             </a:pPr>
             <a:r>
+              <a:rPr sz="1200">
+                <a:solidFill>
+                  <a:srgbClr val="F8FAFC"/>
+                </a:solidFill>
+              </a:rPr>
               <a:t>13 benchmark tender dossiers including authentic CPCL Manali Refinery packages (Technip Energies) and targeted edge cases (expired ISO, turnover deficit, EMD shortfall, and UDYAM MSME relief).</a:t>
             </a:r>
             <a:endParaRPr/>
@@ -17862,6 +18481,9 @@
                 <a:spcPts val="0"/>
               </a:spcAft>
               <a:buNone/>
+              <a:defRPr>
+                <a:solidFill/>
+              </a:defRPr>
             </a:pPr>
             <a:r>
               <a:rPr b="1" i="0" lang="en-US" sz="950">
@@ -17915,9 +18537,18 @@
                 <a:spcPts val="0"/>
               </a:spcAft>
               <a:buNone/>
-              <a:defRPr sz="1200"/>
+              <a:defRPr sz="1200">
+                <a:solidFill>
+                  <a:srgbClr val="F8FAFC"/>
+                </a:solidFill>
+              </a:defRPr>
             </a:pPr>
             <a:r>
+              <a:rPr sz="1200">
+                <a:solidFill>
+                  <a:srgbClr val="F8FAFC"/>
+                </a:solidFill>
+              </a:rPr>
               <a:t>CONDITIONAL verdicts pause for human committee sign-off on borderline MSME exemptions (Clause 4.5) and pending certificate renewals, ensuring complete CVC vigilance compliance.</a:t>
             </a:r>
             <a:endParaRPr/>
@@ -18009,6 +18640,9 @@
                 <a:spcPts val="0"/>
               </a:spcAft>
               <a:buNone/>
+              <a:defRPr>
+                <a:solidFill/>
+              </a:defRPr>
             </a:pPr>
             <a:r>
               <a:rPr b="1" i="0" lang="en-US" sz="1300">
@@ -18059,11 +18693,14 @@
                 <a:spcPts val="0"/>
               </a:spcAft>
               <a:buNone/>
+              <a:defRPr>
+                <a:solidFill/>
+              </a:defRPr>
             </a:pPr>
             <a:r>
               <a:rPr b="0" i="0" lang="en-US" sz="1100">
                 <a:solidFill>
-                  <a:srgbClr val="757068"/>
+                  <a:srgbClr val="E1E6F0"/>
                 </a:solidFill>
                 <a:latin typeface="Space Grotesk"/>
                 <a:ea typeface="Space Grotesk"/>
@@ -18142,6 +18779,9 @@
                 <a:spcPts val="0"/>
               </a:spcAft>
               <a:buNone/>
+              <a:defRPr>
+                <a:solidFill/>
+              </a:defRPr>
             </a:pPr>
             <a:r>
               <a:rPr b="1" i="0" lang="en-US" sz="1100">
@@ -18192,11 +18832,14 @@
                 <a:spcPts val="0"/>
               </a:spcAft>
               <a:buNone/>
+              <a:defRPr>
+                <a:solidFill/>
+              </a:defRPr>
             </a:pPr>
             <a:r>
               <a:rPr b="0" i="0" lang="en-US" sz="900">
                 <a:solidFill>
-                  <a:srgbClr val="757068"/>
+                  <a:srgbClr val="E1E6F0"/>
                 </a:solidFill>
                 <a:latin typeface="JetBrains Mono"/>
                 <a:ea typeface="JetBrains Mono"/>
@@ -18242,6 +18885,9 @@
                 <a:spcPts val="0"/>
               </a:spcAft>
               <a:buNone/>
+              <a:defRPr>
+                <a:solidFill/>
+              </a:defRPr>
             </a:pPr>
             <a:r>
               <a:rPr b="1" i="0" lang="en-US" sz="950">
@@ -18295,6 +18941,9 @@
                 <a:spcPts val="0"/>
               </a:spcAft>
               <a:buNone/>
+              <a:defRPr>
+                <a:solidFill/>
+              </a:defRPr>
             </a:pPr>
             <a:r>
               <a:rPr b="0" i="0" lang="en-US" sz="5000">
@@ -18390,6 +19039,9 @@
                 <a:spcPts val="0"/>
               </a:spcAft>
               <a:buNone/>
+              <a:defRPr>
+                <a:solidFill/>
+              </a:defRPr>
             </a:pPr>
             <a:r>
               <a:rPr b="0" i="1" lang="en-US" sz="2400">
@@ -18440,9 +19092,18 @@
                 <a:spcPts val="0"/>
               </a:spcAft>
               <a:buNone/>
-              <a:defRPr sz="1400" b="1"/>
+              <a:defRPr sz="1400" b="1">
+                <a:solidFill>
+                  <a:srgbClr val="FFD778"/>
+                </a:solidFill>
+              </a:defRPr>
             </a:pPr>
             <a:r>
+              <a:rPr sz="1400" b="1">
+                <a:solidFill>
+                  <a:srgbClr val="FFD778"/>
+                </a:solidFill>
+              </a:rPr>
               <a:t>Zero-Hallucination Solvers</a:t>
             </a:r>
             <a:endParaRPr/>
@@ -18482,9 +19143,18 @@
                 <a:spcPts val="0"/>
               </a:spcAft>
               <a:buNone/>
-              <a:defRPr sz="1200"/>
+              <a:defRPr sz="1200">
+                <a:solidFill>
+                  <a:srgbClr val="F8FAFC"/>
+                </a:solidFill>
+              </a:defRPr>
             </a:pPr>
             <a:r>
+              <a:rPr sz="1200">
+                <a:solidFill>
+                  <a:srgbClr val="F8FAFC"/>
+                </a:solidFill>
+              </a:rPr>
               <a:t>Deterministic regex, Mod-36 checksum, and date-math engines guarantee 100% accuracy on statutory criteria.</a:t>
             </a:r>
             <a:endParaRPr/>
@@ -18557,6 +19227,9 @@
                 <a:spcPts val="0"/>
               </a:spcAft>
               <a:buNone/>
+              <a:defRPr>
+                <a:solidFill/>
+              </a:defRPr>
             </a:pPr>
             <a:r>
               <a:rPr b="0" i="1" lang="en-US" sz="2400">
@@ -18607,9 +19280,18 @@
                 <a:spcPts val="0"/>
               </a:spcAft>
               <a:buNone/>
-              <a:defRPr sz="1400" b="1"/>
+              <a:defRPr sz="1400" b="1">
+                <a:solidFill>
+                  <a:srgbClr val="FFD778"/>
+                </a:solidFill>
+              </a:defRPr>
             </a:pPr>
             <a:r>
+              <a:rPr sz="1400" b="1">
+                <a:solidFill>
+                  <a:srgbClr val="FFD778"/>
+                </a:solidFill>
+              </a:rPr>
               <a:t>Traceable Attribution Graph</a:t>
             </a:r>
             <a:endParaRPr/>
@@ -18649,9 +19331,18 @@
                 <a:spcPts val="0"/>
               </a:spcAft>
               <a:buNone/>
-              <a:defRPr sz="1200"/>
+              <a:defRPr sz="1200">
+                <a:solidFill>
+                  <a:srgbClr val="F8FAFC"/>
+                </a:solidFill>
+              </a:defRPr>
             </a:pPr>
             <a:r>
+              <a:rPr sz="1200">
+                <a:solidFill>
+                  <a:srgbClr val="F8FAFC"/>
+                </a:solidFill>
+              </a:rPr>
               <a:t>Every PASS/FAIL verdict is linked to exact page numbers, clause IDs, and verbatim quotations.</a:t>
             </a:r>
             <a:endParaRPr/>
@@ -18724,6 +19415,9 @@
                 <a:spcPts val="0"/>
               </a:spcAft>
               <a:buNone/>
+              <a:defRPr>
+                <a:solidFill/>
+              </a:defRPr>
             </a:pPr>
             <a:r>
               <a:rPr b="0" i="1" lang="en-US" sz="2400">
@@ -18774,9 +19468,18 @@
                 <a:spcPts val="0"/>
               </a:spcAft>
               <a:buNone/>
-              <a:defRPr sz="1400" b="1"/>
+              <a:defRPr sz="1400" b="1">
+                <a:solidFill>
+                  <a:srgbClr val="FFD778"/>
+                </a:solidFill>
+              </a:defRPr>
             </a:pPr>
             <a:r>
+              <a:rPr sz="1400" b="1">
+                <a:solidFill>
+                  <a:srgbClr val="FFD778"/>
+                </a:solidFill>
+              </a:rPr>
               <a:t>MSME Relief Engine</a:t>
             </a:r>
             <a:endParaRPr/>
@@ -18816,9 +19519,18 @@
                 <a:spcPts val="0"/>
               </a:spcAft>
               <a:buNone/>
-              <a:defRPr sz="1200"/>
+              <a:defRPr sz="1200">
+                <a:solidFill>
+                  <a:srgbClr val="F8FAFC"/>
+                </a:solidFill>
+              </a:defRPr>
             </a:pPr>
             <a:r>
+              <a:rPr sz="1200">
+                <a:solidFill>
+                  <a:srgbClr val="F8FAFC"/>
+                </a:solidFill>
+              </a:rPr>
               <a:t>Recognizes valid UDYAM registrations and applies turnover relaxations under Public Procurement Policy Clause 4.5.</a:t>
             </a:r>
             <a:endParaRPr/>
@@ -18891,6 +19603,9 @@
                 <a:spcPts val="0"/>
               </a:spcAft>
               <a:buNone/>
+              <a:defRPr>
+                <a:solidFill/>
+              </a:defRPr>
             </a:pPr>
             <a:r>
               <a:rPr b="0" i="1" lang="en-US" sz="2400">
@@ -18941,9 +19656,18 @@
                 <a:spcPts val="0"/>
               </a:spcAft>
               <a:buNone/>
-              <a:defRPr sz="1400" b="1"/>
+              <a:defRPr sz="1400" b="1">
+                <a:solidFill>
+                  <a:srgbClr val="FFD778"/>
+                </a:solidFill>
+              </a:defRPr>
             </a:pPr>
             <a:r>
+              <a:rPr sz="1400" b="1">
+                <a:solidFill>
+                  <a:srgbClr val="FFD778"/>
+                </a:solidFill>
+              </a:rPr>
               <a:t>Vigilance-Grade Audit Trail</a:t>
             </a:r>
             <a:endParaRPr/>
@@ -18983,9 +19707,18 @@
                 <a:spcPts val="0"/>
               </a:spcAft>
               <a:buNone/>
-              <a:defRPr sz="1200"/>
+              <a:defRPr sz="1200">
+                <a:solidFill>
+                  <a:srgbClr val="F8FAFC"/>
+                </a:solidFill>
+              </a:defRPr>
             </a:pPr>
             <a:r>
+              <a:rPr sz="1200">
+                <a:solidFill>
+                  <a:srgbClr val="F8FAFC"/>
+                </a:solidFill>
+              </a:rPr>
               <a:t>Exports complete CVC-defensible PDF audit scorecards and full agent execution trajectory logs (.jsonl).</a:t>
             </a:r>
             <a:endParaRPr/>
@@ -19058,6 +19791,9 @@
                 <a:spcPts val="0"/>
               </a:spcAft>
               <a:buNone/>
+              <a:defRPr>
+                <a:solidFill/>
+              </a:defRPr>
             </a:pPr>
             <a:r>
               <a:rPr b="0" i="1" lang="en-US" sz="2400">
@@ -19108,9 +19844,18 @@
                 <a:spcPts val="0"/>
               </a:spcAft>
               <a:buNone/>
-              <a:defRPr sz="1400" b="1"/>
+              <a:defRPr sz="1400" b="1">
+                <a:solidFill>
+                  <a:srgbClr val="FFD778"/>
+                </a:solidFill>
+              </a:defRPr>
             </a:pPr>
             <a:r>
+              <a:rPr sz="1400" b="1">
+                <a:solidFill>
+                  <a:srgbClr val="FFD778"/>
+                </a:solidFill>
+              </a:rPr>
               <a:t>Dual-Persona Interface</a:t>
             </a:r>
             <a:endParaRPr/>
@@ -19150,9 +19895,18 @@
                 <a:spcPts val="0"/>
               </a:spcAft>
               <a:buNone/>
-              <a:defRPr sz="1200"/>
+              <a:defRPr sz="1200">
+                <a:solidFill>
+                  <a:srgbClr val="F8FAFC"/>
+                </a:solidFill>
+              </a:defRPr>
             </a:pPr>
             <a:r>
+              <a:rPr sz="1200">
+                <a:solidFill>
+                  <a:srgbClr val="F8FAFC"/>
+                </a:solidFill>
+              </a:rPr>
               <a:t>Procurement Officer mode with split-screen evidence + MSME Supplier pre-flight self-check mode.</a:t>
             </a:r>
             <a:endParaRPr/>
@@ -19277,6 +20031,9 @@
                 <a:spcPts val="0"/>
               </a:spcAft>
               <a:buNone/>
+              <a:defRPr>
+                <a:solidFill/>
+              </a:defRPr>
             </a:pPr>
             <a:r>
               <a:rPr b="1" i="0" lang="en-US" sz="1300">
@@ -19327,11 +20084,14 @@
                 <a:spcPts val="0"/>
               </a:spcAft>
               <a:buNone/>
+              <a:defRPr>
+                <a:solidFill/>
+              </a:defRPr>
             </a:pPr>
             <a:r>
               <a:rPr b="0" i="0" lang="en-US" sz="1100">
                 <a:solidFill>
-                  <a:srgbClr val="757068"/>
+                  <a:srgbClr val="E1E6F0"/>
                 </a:solidFill>
                 <a:latin typeface="Space Grotesk"/>
                 <a:ea typeface="Space Grotesk"/>
@@ -19410,6 +20170,9 @@
                 <a:spcPts val="0"/>
               </a:spcAft>
               <a:buNone/>
+              <a:defRPr>
+                <a:solidFill/>
+              </a:defRPr>
             </a:pPr>
             <a:r>
               <a:rPr b="1" i="0" lang="en-US" sz="1100">
@@ -19460,11 +20223,14 @@
                 <a:spcPts val="0"/>
               </a:spcAft>
               <a:buNone/>
+              <a:defRPr>
+                <a:solidFill/>
+              </a:defRPr>
             </a:pPr>
             <a:r>
               <a:rPr b="0" i="0" lang="en-US" sz="900">
                 <a:solidFill>
-                  <a:srgbClr val="757068"/>
+                  <a:srgbClr val="E1E6F0"/>
                 </a:solidFill>
                 <a:latin typeface="JetBrains Mono"/>
                 <a:ea typeface="JetBrains Mono"/>
@@ -19510,6 +20276,9 @@
                 <a:spcPts val="0"/>
               </a:spcAft>
               <a:buNone/>
+              <a:defRPr>
+                <a:solidFill/>
+              </a:defRPr>
             </a:pPr>
             <a:r>
               <a:rPr b="1" i="0" lang="en-US" sz="950">
@@ -19563,6 +20332,9 @@
                 <a:spcPts val="0"/>
               </a:spcAft>
               <a:buNone/>
+              <a:defRPr>
+                <a:solidFill/>
+              </a:defRPr>
             </a:pPr>
             <a:r>
               <a:rPr b="0" i="0" lang="en-US" sz="5000">
@@ -19684,6 +20456,9 @@
                 <a:spcPts val="0"/>
               </a:spcAft>
               <a:buNone/>
+              <a:defRPr>
+                <a:solidFill/>
+              </a:defRPr>
             </a:pPr>
             <a:r>
               <a:rPr b="1" i="0" lang="en-US" sz="950">
@@ -19734,9 +20509,18 @@
                 <a:spcPts val="0"/>
               </a:spcAft>
               <a:buNone/>
-              <a:defRPr sz="1600" b="1"/>
+              <a:defRPr sz="1700" b="1">
+                <a:solidFill>
+                  <a:srgbClr val="FFFFFF"/>
+                </a:solidFill>
+              </a:defRPr>
             </a:pPr>
             <a:r>
+              <a:rPr sz="1700" b="1">
+                <a:solidFill>
+                  <a:srgbClr val="FFFFFF"/>
+                </a:solidFill>
+              </a:rPr>
               <a:t>3 to 5 Days (50.0% Accuracy)</a:t>
             </a:r>
             <a:endParaRPr/>
@@ -19779,9 +20563,18 @@
                 <a:spcPts val="0"/>
               </a:spcAft>
               <a:buNone/>
-              <a:defRPr sz="1200"/>
+              <a:defRPr sz="1200">
+                <a:solidFill>
+                  <a:srgbClr val="F8FAFC"/>
+                </a:solidFill>
+              </a:defRPr>
             </a:pPr>
             <a:r>
+              <a:rPr sz="1200">
+                <a:solidFill>
+                  <a:srgbClr val="F8FAFC"/>
+                </a:solidFill>
+              </a:rPr>
               <a:t>Manual committee review takes 3–5 days per tender. Naive keyword baselines score only 50.0% accuracy, missing expired certificates, fake GSTINs, and turnover shortfalls.</a:t>
             </a:r>
             <a:endParaRPr/>
@@ -19880,6 +20673,9 @@
                 <a:spcPts val="0"/>
               </a:spcAft>
               <a:buNone/>
+              <a:defRPr>
+                <a:solidFill/>
+              </a:defRPr>
             </a:pPr>
             <a:r>
               <a:rPr b="1" i="0" lang="en-US" sz="950">
@@ -19930,9 +20726,18 @@
                 <a:spcPts val="0"/>
               </a:spcAft>
               <a:buNone/>
-              <a:defRPr sz="1600" b="1"/>
+              <a:defRPr sz="1700" b="1">
+                <a:solidFill>
+                  <a:srgbClr val="FFD778"/>
+                </a:solidFill>
+              </a:defRPr>
             </a:pPr>
             <a:r>
+              <a:rPr sz="1700" b="1">
+                <a:solidFill>
+                  <a:srgbClr val="FFD778"/>
+                </a:solidFill>
+              </a:rPr>
               <a:t>1.2 Seconds (100.0% Accuracy)</a:t>
             </a:r>
             <a:endParaRPr/>
@@ -19975,9 +20780,18 @@
                 <a:spcPts val="0"/>
               </a:spcAft>
               <a:buNone/>
-              <a:defRPr sz="1200"/>
+              <a:defRPr sz="1200">
+                <a:solidFill>
+                  <a:srgbClr val="F8FAFC"/>
+                </a:solidFill>
+              </a:defRPr>
             </a:pPr>
             <a:r>
+              <a:rPr sz="1200">
+                <a:solidFill>
+                  <a:srgbClr val="F8FAFC"/>
+                </a:solidFill>
+              </a:rPr>
               <a:t>TenderPulse AI cuts review time to 1.2s while achieving 100.0% decision accuracy across all 13 benchmark dossiers (+50.0% gain, zero false positives, 98%+ confidence).</a:t>
             </a:r>
             <a:endParaRPr/>
@@ -20017,6 +20831,9 @@
                 <a:spcPts val="0"/>
               </a:spcAft>
               <a:buNone/>
+              <a:defRPr>
+                <a:solidFill/>
+              </a:defRPr>
             </a:pPr>
             <a:r>
               <a:rPr b="0" i="0" lang="en-US" sz="3000">
@@ -20126,6 +20943,9 @@
                 <a:spcPts val="0"/>
               </a:spcAft>
               <a:buNone/>
+              <a:defRPr>
+                <a:solidFill/>
+              </a:defRPr>
             </a:pPr>
             <a:r>
               <a:rPr b="1" i="0" lang="en-US" sz="950">
@@ -20179,9 +20999,18 @@
                 <a:spcPts val="0"/>
               </a:spcAft>
               <a:buNone/>
-              <a:defRPr sz="1200"/>
+              <a:defRPr sz="1200">
+                <a:solidFill>
+                  <a:srgbClr val="F8FAFC"/>
+                </a:solidFill>
+              </a:defRPr>
             </a:pPr>
             <a:r>
+              <a:rPr sz="1200">
+                <a:solidFill>
+                  <a:srgbClr val="F8FAFC"/>
+                </a:solidFill>
+              </a:rPr>
               <a:t>Evaluated on 13 diverse bid dossiers: 5 fully compliant passes, 6 failure modes (expired ISO, turnover deficit, invalid GSTIN checksum, EMD shortfall, compound failure), and 2 conditional MSME edge cases.</a:t>
             </a:r>
             <a:endParaRPr/>
@@ -20273,6 +21102,9 @@
                 <a:spcPts val="0"/>
               </a:spcAft>
               <a:buNone/>
+              <a:defRPr>
+                <a:solidFill/>
+              </a:defRPr>
             </a:pPr>
             <a:r>
               <a:rPr b="1" i="0" lang="en-US" sz="1300">
@@ -20323,11 +21155,14 @@
                 <a:spcPts val="0"/>
               </a:spcAft>
               <a:buNone/>
+              <a:defRPr>
+                <a:solidFill/>
+              </a:defRPr>
             </a:pPr>
             <a:r>
               <a:rPr b="0" i="0" lang="en-US" sz="1100">
                 <a:solidFill>
-                  <a:srgbClr val="757068"/>
+                  <a:srgbClr val="E1E6F0"/>
                 </a:solidFill>
                 <a:latin typeface="Space Grotesk"/>
                 <a:ea typeface="Space Grotesk"/>
@@ -20406,6 +21241,9 @@
                 <a:spcPts val="0"/>
               </a:spcAft>
               <a:buNone/>
+              <a:defRPr>
+                <a:solidFill/>
+              </a:defRPr>
             </a:pPr>
             <a:r>
               <a:rPr b="1" i="0" lang="en-US" sz="1100">
@@ -20456,11 +21294,14 @@
                 <a:spcPts val="0"/>
               </a:spcAft>
               <a:buNone/>
+              <a:defRPr>
+                <a:solidFill/>
+              </a:defRPr>
             </a:pPr>
             <a:r>
               <a:rPr b="0" i="0" lang="en-US" sz="900">
                 <a:solidFill>
-                  <a:srgbClr val="757068"/>
+                  <a:srgbClr val="E1E6F0"/>
                 </a:solidFill>
                 <a:latin typeface="JetBrains Mono"/>
                 <a:ea typeface="JetBrains Mono"/>
@@ -20506,6 +21347,9 @@
                 <a:spcPts val="0"/>
               </a:spcAft>
               <a:buNone/>
+              <a:defRPr>
+                <a:solidFill/>
+              </a:defRPr>
             </a:pPr>
             <a:r>
               <a:rPr b="1" i="0" lang="en-US" sz="950">
@@ -20559,9 +21403,18 @@
                 <a:spcPts val="0"/>
               </a:spcAft>
               <a:buNone/>
-              <a:defRPr sz="2800" b="1"/>
+              <a:defRPr sz="2800" b="1">
+                <a:solidFill>
+                  <a:srgbClr val="FFFFFF"/>
+                </a:solidFill>
+              </a:defRPr>
             </a:pPr>
             <a:r>
+              <a:rPr sz="2800" b="1">
+                <a:solidFill>
+                  <a:srgbClr val="FFFFFF"/>
+                </a:solidFill>
+              </a:rPr>
               <a:t>TeAm AsPirE</a:t>
             </a:r>
             <a:endParaRPr/>
@@ -20660,6 +21513,9 @@
                 <a:spcPts val="0"/>
               </a:spcAft>
               <a:buNone/>
+              <a:defRPr>
+                <a:solidFill/>
+              </a:defRPr>
             </a:pPr>
             <a:r>
               <a:rPr b="1" i="0" lang="en-US" sz="950">
@@ -20710,9 +21566,18 @@
                 <a:spcPts val="0"/>
               </a:spcAft>
               <a:buNone/>
-              <a:defRPr sz="1600" b="1"/>
+              <a:defRPr sz="1700" b="1">
+                <a:solidFill>
+                  <a:srgbClr val="FFD778"/>
+                </a:solidFill>
+              </a:defRPr>
             </a:pPr>
             <a:r>
+              <a:rPr sz="1700" b="1">
+                <a:solidFill>
+                  <a:srgbClr val="FFD778"/>
+                </a:solidFill>
+              </a:rPr>
               <a:t>Darshan S</a:t>
             </a:r>
             <a:endParaRPr/>
@@ -20752,11 +21617,14 @@
                 <a:spcPts val="0"/>
               </a:spcAft>
               <a:buNone/>
+              <a:defRPr>
+                <a:solidFill/>
+              </a:defRPr>
             </a:pPr>
             <a:r>
-              <a:rPr b="0" i="0" lang="en-US" sz="850">
-                <a:solidFill>
-                  <a:srgbClr val="757068"/>
+              <a:rPr b="1" i="0" lang="en-US" sz="850">
+                <a:solidFill>
+                  <a:srgbClr val="F5B937"/>
                 </a:solidFill>
                 <a:latin typeface="JetBrains Mono"/>
                 <a:ea typeface="JetBrains Mono"/>
@@ -20802,9 +21670,18 @@
                 <a:spcPts val="0"/>
               </a:spcAft>
               <a:buNone/>
-              <a:defRPr sz="1200"/>
+              <a:defRPr sz="1200">
+                <a:solidFill>
+                  <a:srgbClr val="F8FAFC"/>
+                </a:solidFill>
+              </a:defRPr>
             </a:pPr>
             <a:r>
+              <a:rPr sz="1200">
+                <a:solidFill>
+                  <a:srgbClr val="F8FAFC"/>
+                </a:solidFill>
+              </a:rPr>
               <a:t>Engineering &amp; Technology</a:t>
             </a:r>
             <a:endParaRPr/>
@@ -20844,11 +21721,14 @@
                 <a:spcPts val="0"/>
               </a:spcAft>
               <a:buNone/>
+              <a:defRPr>
+                <a:solidFill/>
+              </a:defRPr>
             </a:pPr>
             <a:r>
-              <a:rPr b="0" i="0" lang="en-US" sz="850">
-                <a:solidFill>
-                  <a:srgbClr val="757068"/>
+              <a:rPr b="1" i="0" lang="en-US" sz="850">
+                <a:solidFill>
+                  <a:srgbClr val="F5B937"/>
                 </a:solidFill>
                 <a:latin typeface="JetBrains Mono"/>
                 <a:ea typeface="JetBrains Mono"/>
@@ -20894,9 +21774,18 @@
                 <a:spcPts val="0"/>
               </a:spcAft>
               <a:buNone/>
-              <a:defRPr sz="1200"/>
+              <a:defRPr sz="1200">
+                <a:solidFill>
+                  <a:srgbClr val="F8FAFC"/>
+                </a:solidFill>
+              </a:defRPr>
             </a:pPr>
             <a:r>
+              <a:rPr sz="1200">
+                <a:solidFill>
+                  <a:srgbClr val="F8FAFC"/>
+                </a:solidFill>
+              </a:rPr>
               <a:t>Final Year (4th Year B.E.)</a:t>
             </a:r>
             <a:endParaRPr/>
@@ -20936,11 +21825,14 @@
                 <a:spcPts val="0"/>
               </a:spcAft>
               <a:buNone/>
+              <a:defRPr>
+                <a:solidFill/>
+              </a:defRPr>
             </a:pPr>
             <a:r>
-              <a:rPr b="0" i="0" lang="en-US" sz="850">
-                <a:solidFill>
-                  <a:srgbClr val="757068"/>
+              <a:rPr b="1" i="0" lang="en-US" sz="850">
+                <a:solidFill>
+                  <a:srgbClr val="F5B937"/>
                 </a:solidFill>
                 <a:latin typeface="JetBrains Mono"/>
                 <a:ea typeface="JetBrains Mono"/>
@@ -20986,9 +21878,18 @@
                 <a:spcPts val="0"/>
               </a:spcAft>
               <a:buNone/>
-              <a:defRPr sz="1100"/>
+              <a:defRPr sz="1100">
+                <a:solidFill>
+                  <a:srgbClr val="F8FAFC"/>
+                </a:solidFill>
+              </a:defRPr>
             </a:pPr>
             <a:r>
+              <a:rPr sz="1100">
+                <a:solidFill>
+                  <a:srgbClr val="F8FAFC"/>
+                </a:solidFill>
+              </a:rPr>
               <a:t>Full-Stack AI Architecture, Solvers &amp; Dashboard</a:t>
             </a:r>
             <a:endParaRPr/>
@@ -21028,11 +21929,14 @@
                 <a:spcPts val="0"/>
               </a:spcAft>
               <a:buNone/>
+              <a:defRPr>
+                <a:solidFill/>
+              </a:defRPr>
             </a:pPr>
             <a:r>
-              <a:rPr b="0" i="0" lang="en-US" sz="850">
-                <a:solidFill>
-                  <a:srgbClr val="757068"/>
+              <a:rPr b="1" i="0" lang="en-US" sz="850">
+                <a:solidFill>
+                  <a:srgbClr val="F5B937"/>
                 </a:solidFill>
                 <a:latin typeface="JetBrains Mono"/>
                 <a:ea typeface="JetBrains Mono"/>
@@ -21078,9 +21982,18 @@
                 <a:spcPts val="0"/>
               </a:spcAft>
               <a:buNone/>
-              <a:defRPr sz="1100"/>
+              <a:defRPr sz="1100">
+                <a:solidFill>
+                  <a:srgbClr val="FFD778"/>
+                </a:solidFill>
+              </a:defRPr>
             </a:pPr>
             <a:r>
+              <a:rPr sz="1100">
+                <a:solidFill>
+                  <a:srgbClr val="FFD778"/>
+                </a:solidFill>
+              </a:rPr>
               <a:t>https://github.com/darshan-s-44</a:t>
             </a:r>
             <a:endParaRPr/>
@@ -21179,6 +22092,9 @@
                 <a:spcPts val="0"/>
               </a:spcAft>
               <a:buNone/>
+              <a:defRPr>
+                <a:solidFill/>
+              </a:defRPr>
             </a:pPr>
             <a:r>
               <a:rPr b="1" i="0" lang="en-US" sz="950">
@@ -21229,9 +22145,18 @@
                 <a:spcPts val="0"/>
               </a:spcAft>
               <a:buNone/>
-              <a:defRPr sz="1600" b="1"/>
+              <a:defRPr sz="1700" b="1">
+                <a:solidFill>
+                  <a:srgbClr val="FFD778"/>
+                </a:solidFill>
+              </a:defRPr>
             </a:pPr>
             <a:r>
+              <a:rPr sz="1700" b="1">
+                <a:solidFill>
+                  <a:srgbClr val="FFD778"/>
+                </a:solidFill>
+              </a:rPr>
               <a:t>AI Decision Agent</a:t>
             </a:r>
             <a:endParaRPr/>
@@ -21271,11 +22196,14 @@
                 <a:spcPts val="0"/>
               </a:spcAft>
               <a:buNone/>
+              <a:defRPr>
+                <a:solidFill/>
+              </a:defRPr>
             </a:pPr>
             <a:r>
-              <a:rPr b="0" i="0" lang="en-US" sz="850">
-                <a:solidFill>
-                  <a:srgbClr val="757068"/>
+              <a:rPr b="1" i="0" lang="en-US" sz="850">
+                <a:solidFill>
+                  <a:srgbClr val="F5B937"/>
                 </a:solidFill>
                 <a:latin typeface="JetBrains Mono"/>
                 <a:ea typeface="JetBrains Mono"/>
@@ -21321,9 +22249,18 @@
                 <a:spcPts val="0"/>
               </a:spcAft>
               <a:buNone/>
-              <a:defRPr sz="1200"/>
+              <a:defRPr sz="1200">
+                <a:solidFill>
+                  <a:srgbClr val="F8FAFC"/>
+                </a:solidFill>
+              </a:defRPr>
             </a:pPr>
             <a:r>
+              <a:rPr sz="1200">
+                <a:solidFill>
+                  <a:srgbClr val="F8FAFC"/>
+                </a:solidFill>
+              </a:rPr>
               <a:t>TenderPulse Core</a:t>
             </a:r>
             <a:endParaRPr/>
@@ -21363,11 +22300,14 @@
                 <a:spcPts val="0"/>
               </a:spcAft>
               <a:buNone/>
+              <a:defRPr>
+                <a:solidFill/>
+              </a:defRPr>
             </a:pPr>
             <a:r>
-              <a:rPr b="0" i="0" lang="en-US" sz="850">
-                <a:solidFill>
-                  <a:srgbClr val="757068"/>
+              <a:rPr b="1" i="0" lang="en-US" sz="850">
+                <a:solidFill>
+                  <a:srgbClr val="F5B937"/>
                 </a:solidFill>
                 <a:latin typeface="JetBrains Mono"/>
                 <a:ea typeface="JetBrains Mono"/>
@@ -21413,9 +22353,18 @@
                 <a:spcPts val="0"/>
               </a:spcAft>
               <a:buNone/>
-              <a:defRPr sz="1200"/>
+              <a:defRPr sz="1200">
+                <a:solidFill>
+                  <a:srgbClr val="F8FAFC"/>
+                </a:solidFill>
+              </a:defRPr>
             </a:pPr>
             <a:r>
+              <a:rPr sz="1200">
+                <a:solidFill>
+                  <a:srgbClr val="F8FAFC"/>
+                </a:solidFill>
+              </a:rPr>
               <a:t>Production Layer</a:t>
             </a:r>
             <a:endParaRPr/>
@@ -21455,11 +22404,14 @@
                 <a:spcPts val="0"/>
               </a:spcAft>
               <a:buNone/>
+              <a:defRPr>
+                <a:solidFill/>
+              </a:defRPr>
             </a:pPr>
             <a:r>
-              <a:rPr b="0" i="0" lang="en-US" sz="850">
-                <a:solidFill>
-                  <a:srgbClr val="757068"/>
+              <a:rPr b="1" i="0" lang="en-US" sz="850">
+                <a:solidFill>
+                  <a:srgbClr val="F5B937"/>
                 </a:solidFill>
                 <a:latin typeface="JetBrains Mono"/>
                 <a:ea typeface="JetBrains Mono"/>
@@ -21505,9 +22457,18 @@
                 <a:spcPts val="0"/>
               </a:spcAft>
               <a:buNone/>
-              <a:defRPr sz="1100"/>
+              <a:defRPr sz="1100">
+                <a:solidFill>
+                  <a:srgbClr val="F8FAFC"/>
+                </a:solidFill>
+              </a:defRPr>
             </a:pPr>
             <a:r>
+              <a:rPr sz="1100">
+                <a:solidFill>
+                  <a:srgbClr val="F8FAFC"/>
+                </a:solidFill>
+              </a:rPr>
               <a:t>Multi-Tool Rule Solvers &amp; Layout Ingestion</a:t>
             </a:r>
             <a:endParaRPr/>
@@ -21547,11 +22508,14 @@
                 <a:spcPts val="0"/>
               </a:spcAft>
               <a:buNone/>
+              <a:defRPr>
+                <a:solidFill/>
+              </a:defRPr>
             </a:pPr>
             <a:r>
-              <a:rPr b="0" i="0" lang="en-US" sz="850">
-                <a:solidFill>
-                  <a:srgbClr val="757068"/>
+              <a:rPr b="1" i="0" lang="en-US" sz="850">
+                <a:solidFill>
+                  <a:srgbClr val="F5B937"/>
                 </a:solidFill>
                 <a:latin typeface="JetBrains Mono"/>
                 <a:ea typeface="JetBrains Mono"/>
@@ -21597,9 +22561,18 @@
                 <a:spcPts val="0"/>
               </a:spcAft>
               <a:buNone/>
-              <a:defRPr sz="1100"/>
+              <a:defRPr sz="1100">
+                <a:solidFill>
+                  <a:srgbClr val="FFD778"/>
+                </a:solidFill>
+              </a:defRPr>
             </a:pPr>
             <a:r>
+              <a:rPr sz="1100">
+                <a:solidFill>
+                  <a:srgbClr val="FFD778"/>
+                </a:solidFill>
+              </a:rPr>
               <a:t>https://ai-build-hackathon.onrender.com</a:t>
             </a:r>
             <a:endParaRPr/>
@@ -21698,6 +22671,9 @@
                 <a:spcPts val="0"/>
               </a:spcAft>
               <a:buNone/>
+              <a:defRPr>
+                <a:solidFill/>
+              </a:defRPr>
             </a:pPr>
             <a:r>
               <a:rPr b="1" i="0" lang="en-US" sz="950">
@@ -21748,9 +22724,18 @@
                 <a:spcPts val="0"/>
               </a:spcAft>
               <a:buNone/>
-              <a:defRPr sz="1600" b="1"/>
+              <a:defRPr sz="1700" b="1">
+                <a:solidFill>
+                  <a:srgbClr val="FFD778"/>
+                </a:solidFill>
+              </a:defRPr>
             </a:pPr>
             <a:r>
+              <a:rPr sz="1700" b="1">
+                <a:solidFill>
+                  <a:srgbClr val="FFD778"/>
+                </a:solidFill>
+              </a:rPr>
               <a:t>Audit Reflection Guardrail</a:t>
             </a:r>
             <a:endParaRPr/>
@@ -21790,11 +22775,14 @@
                 <a:spcPts val="0"/>
               </a:spcAft>
               <a:buNone/>
+              <a:defRPr>
+                <a:solidFill/>
+              </a:defRPr>
             </a:pPr>
             <a:r>
-              <a:rPr b="0" i="0" lang="en-US" sz="850">
-                <a:solidFill>
-                  <a:srgbClr val="757068"/>
+              <a:rPr b="1" i="0" lang="en-US" sz="850">
+                <a:solidFill>
+                  <a:srgbClr val="F5B937"/>
                 </a:solidFill>
                 <a:latin typeface="JetBrains Mono"/>
                 <a:ea typeface="JetBrains Mono"/>
@@ -21840,9 +22828,18 @@
                 <a:spcPts val="0"/>
               </a:spcAft>
               <a:buNone/>
-              <a:defRPr sz="1200"/>
+              <a:defRPr sz="1200">
+                <a:solidFill>
+                  <a:srgbClr val="F8FAFC"/>
+                </a:solidFill>
+              </a:defRPr>
             </a:pPr>
             <a:r>
+              <a:rPr sz="1200">
+                <a:solidFill>
+                  <a:srgbClr val="F8FAFC"/>
+                </a:solidFill>
+              </a:rPr>
               <a:t>CVC Compliance Engine</a:t>
             </a:r>
             <a:endParaRPr/>
@@ -21882,11 +22879,14 @@
                 <a:spcPts val="0"/>
               </a:spcAft>
               <a:buNone/>
+              <a:defRPr>
+                <a:solidFill/>
+              </a:defRPr>
             </a:pPr>
             <a:r>
-              <a:rPr b="0" i="0" lang="en-US" sz="850">
-                <a:solidFill>
-                  <a:srgbClr val="757068"/>
+              <a:rPr b="1" i="0" lang="en-US" sz="850">
+                <a:solidFill>
+                  <a:srgbClr val="F5B937"/>
                 </a:solidFill>
                 <a:latin typeface="JetBrains Mono"/>
                 <a:ea typeface="JetBrains Mono"/>
@@ -21932,9 +22932,18 @@
                 <a:spcPts val="0"/>
               </a:spcAft>
               <a:buNone/>
-              <a:defRPr sz="1200"/>
+              <a:defRPr sz="1200">
+                <a:solidFill>
+                  <a:srgbClr val="F8FAFC"/>
+                </a:solidFill>
+              </a:defRPr>
             </a:pPr>
             <a:r>
+              <a:rPr sz="1200">
+                <a:solidFill>
+                  <a:srgbClr val="F8FAFC"/>
+                </a:solidFill>
+              </a:rPr>
               <a:t>Verification Layer</a:t>
             </a:r>
             <a:endParaRPr/>
@@ -21974,11 +22983,14 @@
                 <a:spcPts val="0"/>
               </a:spcAft>
               <a:buNone/>
+              <a:defRPr>
+                <a:solidFill/>
+              </a:defRPr>
             </a:pPr>
             <a:r>
-              <a:rPr b="0" i="0" lang="en-US" sz="850">
-                <a:solidFill>
-                  <a:srgbClr val="757068"/>
+              <a:rPr b="1" i="0" lang="en-US" sz="850">
+                <a:solidFill>
+                  <a:srgbClr val="F5B937"/>
                 </a:solidFill>
                 <a:latin typeface="JetBrains Mono"/>
                 <a:ea typeface="JetBrains Mono"/>
@@ -22024,9 +23036,18 @@
                 <a:spcPts val="0"/>
               </a:spcAft>
               <a:buNone/>
-              <a:defRPr sz="1100"/>
+              <a:defRPr sz="1100">
+                <a:solidFill>
+                  <a:srgbClr val="F8FAFC"/>
+                </a:solidFill>
+              </a:defRPr>
             </a:pPr>
             <a:r>
+              <a:rPr sz="1100">
+                <a:solidFill>
+                  <a:srgbClr val="F8FAFC"/>
+                </a:solidFill>
+              </a:rPr>
               <a:t>Self-Correction &amp; Trajectory Logging</a:t>
             </a:r>
             <a:endParaRPr/>
@@ -22066,11 +23087,14 @@
                 <a:spcPts val="0"/>
               </a:spcAft>
               <a:buNone/>
+              <a:defRPr>
+                <a:solidFill/>
+              </a:defRPr>
             </a:pPr>
             <a:r>
-              <a:rPr b="0" i="0" lang="en-US" sz="850">
-                <a:solidFill>
-                  <a:srgbClr val="757068"/>
+              <a:rPr b="1" i="0" lang="en-US" sz="850">
+                <a:solidFill>
+                  <a:srgbClr val="F5B937"/>
                 </a:solidFill>
                 <a:latin typeface="JetBrains Mono"/>
                 <a:ea typeface="JetBrains Mono"/>
@@ -22116,9 +23140,18 @@
                 <a:spcPts val="0"/>
               </a:spcAft>
               <a:buNone/>
-              <a:defRPr sz="1100"/>
+              <a:defRPr sz="1100">
+                <a:solidFill>
+                  <a:srgbClr val="FFD778"/>
+                </a:solidFill>
+              </a:defRPr>
             </a:pPr>
             <a:r>
+              <a:rPr sz="1100">
+                <a:solidFill>
+                  <a:srgbClr val="FFD778"/>
+                </a:solidFill>
+              </a:rPr>
               <a:t>https://ai-build-hackathon.onrender.com</a:t>
             </a:r>
             <a:endParaRPr/>

</xml_diff>

<commit_message>
Update team slide to solo member layout for Darshan S and brighten presentation
</commit_message>
<xml_diff>
--- a/TenderPulse_AI_Presentation.pptx
+++ b/TenderPulse_AI_Presentation.pptx
@@ -12056,7 +12056,7 @@
                   <a:srgbClr val="FFFFFF"/>
                 </a:solidFill>
               </a:rPr>
-              <a:t>Darshan S (Team Lead)</a:t>
+              <a:t>Darshan S</a:t>
             </a:r>
             <a:endParaRPr/>
           </a:p>
@@ -21429,8 +21429,8 @@
         </p:nvSpPr>
         <p:spPr>
           <a:xfrm>
-            <a:off x="711182" y="2666933"/>
-            <a:ext cx="3428914" cy="3174920"/>
+            <a:off x="3259836" y="2633472"/>
+            <a:ext cx="5669280" cy="3291840"/>
           </a:xfrm>
           <a:prstGeom prst="roundRect">
             <a:avLst>
@@ -21488,8 +21488,8 @@
         </p:nvSpPr>
         <p:spPr>
           <a:xfrm>
-            <a:off x="939776" y="2870128"/>
-            <a:ext cx="2984425" cy="190495"/>
+            <a:off x="3579876" y="2862072"/>
+            <a:ext cx="5029200" cy="190495"/>
           </a:xfrm>
           <a:prstGeom prst="rect">
             <a:avLst/>
@@ -21513,21 +21513,19 @@
                 <a:spcPts val="0"/>
               </a:spcAft>
               <a:buNone/>
-              <a:defRPr>
-                <a:solidFill/>
+              <a:defRPr sz="1100" b="1">
+                <a:solidFill>
+                  <a:srgbClr val="F5B937"/>
+                </a:solidFill>
               </a:defRPr>
             </a:pPr>
             <a:r>
-              <a:rPr b="1" i="0" lang="en-US" sz="950">
-                <a:solidFill>
-                  <a:srgbClr val="F2B632"/>
-                </a:solidFill>
-                <a:latin typeface="JetBrains Mono"/>
-                <a:ea typeface="JetBrains Mono"/>
-                <a:cs typeface="JetBrains Mono"/>
-                <a:sym typeface="JetBrains Mono"/>
+              <a:rPr sz="1100" b="1">
+                <a:solidFill>
+                  <a:srgbClr val="F5B937"/>
+                </a:solidFill>
               </a:rPr>
-              <a:t>MEMBER 01</a:t>
+              <a:t>TEAM LEAD &amp; SOLE DEVELOPER</a:t>
             </a:r>
             <a:endParaRPr/>
           </a:p>
@@ -21541,8 +21539,8 @@
         </p:nvSpPr>
         <p:spPr>
           <a:xfrm>
-            <a:off x="939776" y="3174920"/>
-            <a:ext cx="2984425" cy="444488"/>
+            <a:off x="3579876" y="3136392"/>
+            <a:ext cx="5029200" cy="444488"/>
           </a:xfrm>
           <a:prstGeom prst="rect">
             <a:avLst/>
@@ -21566,14 +21564,14 @@
                 <a:spcPts val="0"/>
               </a:spcAft>
               <a:buNone/>
-              <a:defRPr sz="1700" b="1">
+              <a:defRPr sz="2400" b="1">
                 <a:solidFill>
                   <a:srgbClr val="FFD778"/>
                 </a:solidFill>
               </a:defRPr>
             </a:pPr>
             <a:r>
-              <a:rPr sz="1700" b="1">
+              <a:rPr sz="2400" b="1">
                 <a:solidFill>
                   <a:srgbClr val="FFD778"/>
                 </a:solidFill>
@@ -21592,8 +21590,8 @@
         </p:nvSpPr>
         <p:spPr>
           <a:xfrm>
-            <a:off x="939776" y="3873403"/>
-            <a:ext cx="1015974" cy="253993"/>
+            <a:off x="3579876" y="3822192"/>
+            <a:ext cx="1005840" cy="253993"/>
           </a:xfrm>
           <a:prstGeom prst="rect">
             <a:avLst/>
@@ -21617,19 +21615,17 @@
                 <a:spcPts val="0"/>
               </a:spcAft>
               <a:buNone/>
-              <a:defRPr>
-                <a:solidFill/>
+              <a:defRPr sz="1100" b="1">
+                <a:solidFill>
+                  <a:srgbClr val="F5B937"/>
+                </a:solidFill>
               </a:defRPr>
             </a:pPr>
             <a:r>
-              <a:rPr b="1" i="0" lang="en-US" sz="850">
+              <a:rPr sz="1100" b="1">
                 <a:solidFill>
                   <a:srgbClr val="F5B937"/>
                 </a:solidFill>
-                <a:latin typeface="JetBrains Mono"/>
-                <a:ea typeface="JetBrains Mono"/>
-                <a:cs typeface="JetBrains Mono"/>
-                <a:sym typeface="JetBrains Mono"/>
               </a:rPr>
               <a:t>COLLEGE</a:t>
             </a:r>
@@ -21645,8 +21641,8 @@
         </p:nvSpPr>
         <p:spPr>
           <a:xfrm>
-            <a:off x="1981150" y="3848003"/>
-            <a:ext cx="1968450" cy="380990"/>
+            <a:off x="4631436" y="3794760"/>
+            <a:ext cx="3977640" cy="380990"/>
           </a:xfrm>
           <a:prstGeom prst="rect">
             <a:avLst/>
@@ -21696,8 +21692,8 @@
         </p:nvSpPr>
         <p:spPr>
           <a:xfrm>
-            <a:off x="939776" y="4330591"/>
-            <a:ext cx="1015974" cy="253993"/>
+            <a:off x="3579876" y="4279392"/>
+            <a:ext cx="1005840" cy="253993"/>
           </a:xfrm>
           <a:prstGeom prst="rect">
             <a:avLst/>
@@ -21721,19 +21717,17 @@
                 <a:spcPts val="0"/>
               </a:spcAft>
               <a:buNone/>
-              <a:defRPr>
-                <a:solidFill/>
+              <a:defRPr sz="1100" b="1">
+                <a:solidFill>
+                  <a:srgbClr val="F5B937"/>
+                </a:solidFill>
               </a:defRPr>
             </a:pPr>
             <a:r>
-              <a:rPr b="1" i="0" lang="en-US" sz="850">
+              <a:rPr sz="1100" b="1">
                 <a:solidFill>
                   <a:srgbClr val="F5B937"/>
                 </a:solidFill>
-                <a:latin typeface="JetBrains Mono"/>
-                <a:ea typeface="JetBrains Mono"/>
-                <a:cs typeface="JetBrains Mono"/>
-                <a:sym typeface="JetBrains Mono"/>
               </a:rPr>
               <a:t>YEAR</a:t>
             </a:r>
@@ -21749,8 +21743,8 @@
         </p:nvSpPr>
         <p:spPr>
           <a:xfrm>
-            <a:off x="1981150" y="4305192"/>
-            <a:ext cx="1968450" cy="380990"/>
+            <a:off x="4631436" y="4251960"/>
+            <a:ext cx="3977640" cy="380990"/>
           </a:xfrm>
           <a:prstGeom prst="rect">
             <a:avLst/>
@@ -21800,8 +21794,8 @@
         </p:nvSpPr>
         <p:spPr>
           <a:xfrm>
-            <a:off x="939776" y="4787780"/>
-            <a:ext cx="1015974" cy="253993"/>
+            <a:off x="3579876" y="4736592"/>
+            <a:ext cx="1005840" cy="253993"/>
           </a:xfrm>
           <a:prstGeom prst="rect">
             <a:avLst/>
@@ -21825,19 +21819,17 @@
                 <a:spcPts val="0"/>
               </a:spcAft>
               <a:buNone/>
-              <a:defRPr>
-                <a:solidFill/>
+              <a:defRPr sz="1100" b="1">
+                <a:solidFill>
+                  <a:srgbClr val="F5B937"/>
+                </a:solidFill>
               </a:defRPr>
             </a:pPr>
             <a:r>
-              <a:rPr b="1" i="0" lang="en-US" sz="850">
+              <a:rPr sz="1100" b="1">
                 <a:solidFill>
                   <a:srgbClr val="F5B937"/>
                 </a:solidFill>
-                <a:latin typeface="JetBrains Mono"/>
-                <a:ea typeface="JetBrains Mono"/>
-                <a:cs typeface="JetBrains Mono"/>
-                <a:sym typeface="JetBrains Mono"/>
               </a:rPr>
               <a:t>ROLE</a:t>
             </a:r>
@@ -21853,8 +21845,8 @@
         </p:nvSpPr>
         <p:spPr>
           <a:xfrm>
-            <a:off x="1981150" y="4762380"/>
-            <a:ext cx="1968450" cy="380990"/>
+            <a:off x="4631436" y="4709160"/>
+            <a:ext cx="3977640" cy="380990"/>
           </a:xfrm>
           <a:prstGeom prst="rect">
             <a:avLst/>
@@ -21878,14 +21870,14 @@
                 <a:spcPts val="0"/>
               </a:spcAft>
               <a:buNone/>
-              <a:defRPr sz="1100">
+              <a:defRPr sz="1200">
                 <a:solidFill>
                   <a:srgbClr val="F8FAFC"/>
                 </a:solidFill>
               </a:defRPr>
             </a:pPr>
             <a:r>
-              <a:rPr sz="1100">
+              <a:rPr sz="1200">
                 <a:solidFill>
                   <a:srgbClr val="F8FAFC"/>
                 </a:solidFill>
@@ -21904,8 +21896,8 @@
         </p:nvSpPr>
         <p:spPr>
           <a:xfrm>
-            <a:off x="939776" y="5244968"/>
-            <a:ext cx="1015974" cy="253993"/>
+            <a:off x="3579876" y="5193792"/>
+            <a:ext cx="1005840" cy="253993"/>
           </a:xfrm>
           <a:prstGeom prst="rect">
             <a:avLst/>
@@ -21929,21 +21921,19 @@
                 <a:spcPts val="0"/>
               </a:spcAft>
               <a:buNone/>
-              <a:defRPr>
-                <a:solidFill/>
+              <a:defRPr sz="1100" b="1">
+                <a:solidFill>
+                  <a:srgbClr val="F5B937"/>
+                </a:solidFill>
               </a:defRPr>
             </a:pPr>
             <a:r>
-              <a:rPr b="1" i="0" lang="en-US" sz="850">
+              <a:rPr sz="1100" b="1">
                 <a:solidFill>
                   <a:srgbClr val="F5B937"/>
                 </a:solidFill>
-                <a:latin typeface="JetBrains Mono"/>
-                <a:ea typeface="JetBrains Mono"/>
-                <a:cs typeface="JetBrains Mono"/>
-                <a:sym typeface="JetBrains Mono"/>
               </a:rPr>
-              <a:t>LINKEDIN</a:t>
+              <a:t>GITHUB</a:t>
             </a:r>
             <a:endParaRPr/>
           </a:p>
@@ -21957,8 +21947,8 @@
         </p:nvSpPr>
         <p:spPr>
           <a:xfrm>
-            <a:off x="1981150" y="5219569"/>
-            <a:ext cx="1968450" cy="380990"/>
+            <a:off x="4631436" y="5166360"/>
+            <a:ext cx="3977640" cy="380990"/>
           </a:xfrm>
           <a:prstGeom prst="rect">
             <a:avLst/>
@@ -21982,1177 +21972,19 @@
                 <a:spcPts val="0"/>
               </a:spcAft>
               <a:buNone/>
-              <a:defRPr sz="1100">
+              <a:defRPr sz="1200">
                 <a:solidFill>
                   <a:srgbClr val="FFD778"/>
-                </a:solidFill>
-              </a:defRPr>
-            </a:pPr>
-            <a:r>
-              <a:rPr sz="1100">
-                <a:solidFill>
-                  <a:srgbClr val="FFD778"/>
-                </a:solidFill>
-              </a:rPr>
-              <a:t>https://github.com/darshan-s-44</a:t>
-            </a:r>
-            <a:endParaRPr/>
-          </a:p>
-        </p:txBody>
-      </p:sp>
-      <p:sp>
-        <p:nvSpPr>
-          <p:cNvPr id="310" name="Google Shape;310;p21"/>
-          <p:cNvSpPr/>
-          <p:nvPr/>
-        </p:nvSpPr>
-        <p:spPr>
-          <a:xfrm>
-            <a:off x="4381390" y="2666933"/>
-            <a:ext cx="3428914" cy="3174920"/>
-          </a:xfrm>
-          <a:prstGeom prst="roundRect">
-            <a:avLst>
-              <a:gd fmla="val 6000" name="adj"/>
-            </a:avLst>
-          </a:prstGeom>
-          <a:solidFill>
-            <a:srgbClr val="17130E"/>
-          </a:solidFill>
-          <a:ln cap="flat" cmpd="sng" w="12700">
-            <a:solidFill>
-              <a:srgbClr val="332D25"/>
-            </a:solidFill>
-            <a:prstDash val="solid"/>
-            <a:round/>
-            <a:headEnd len="sm" w="sm" type="none"/>
-            <a:tailEnd len="sm" w="sm" type="none"/>
-          </a:ln>
-        </p:spPr>
-        <p:txBody>
-          <a:bodyPr anchorCtr="0" anchor="ctr" bIns="45700" lIns="91425" spcFirstLastPara="1" rIns="91425" wrap="square" tIns="45700">
-            <a:noAutofit/>
-          </a:bodyPr>
-          <a:lstStyle/>
-          <a:p>
-            <a:pPr indent="0" lvl="0" marL="0" marR="0" rtl="0" algn="l">
-              <a:spcBef>
-                <a:spcPts val="0"/>
-              </a:spcBef>
-              <a:spcAft>
-                <a:spcPts val="0"/>
-              </a:spcAft>
-              <a:buNone/>
-            </a:pPr>
-            <a:r>
-              <a:t/>
-            </a:r>
-            <a:endParaRPr sz="1800">
-              <a:solidFill>
-                <a:schemeClr val="dk1"/>
-              </a:solidFill>
-              <a:latin typeface="Calibri"/>
-              <a:ea typeface="Calibri"/>
-              <a:cs typeface="Calibri"/>
-              <a:sym typeface="Calibri"/>
-            </a:endParaRPr>
-          </a:p>
-        </p:txBody>
-      </p:sp>
-      <p:sp>
-        <p:nvSpPr>
-          <p:cNvPr id="311" name="Google Shape;311;p21"/>
-          <p:cNvSpPr txBox="1"/>
-          <p:nvPr/>
-        </p:nvSpPr>
-        <p:spPr>
-          <a:xfrm>
-            <a:off x="4609984" y="2870128"/>
-            <a:ext cx="2984425" cy="190495"/>
-          </a:xfrm>
-          <a:prstGeom prst="rect">
-            <a:avLst/>
-          </a:prstGeom>
-          <a:noFill/>
-          <a:ln>
-            <a:noFill/>
-          </a:ln>
-        </p:spPr>
-        <p:txBody>
-          <a:bodyPr anchorCtr="0" anchor="t" bIns="0" lIns="0" spcFirstLastPara="1" rIns="0" wrap="square" tIns="0">
-            <a:spAutoFit/>
-          </a:bodyPr>
-          <a:lstStyle/>
-          <a:p>
-            <a:pPr indent="0" lvl="0" marL="0" marR="0" rtl="0" algn="l">
-              <a:spcBef>
-                <a:spcPts val="0"/>
-              </a:spcBef>
-              <a:spcAft>
-                <a:spcPts val="0"/>
-              </a:spcAft>
-              <a:buNone/>
-              <a:defRPr>
-                <a:solidFill/>
-              </a:defRPr>
-            </a:pPr>
-            <a:r>
-              <a:rPr b="1" i="0" lang="en-US" sz="950">
-                <a:solidFill>
-                  <a:srgbClr val="F2B632"/>
-                </a:solidFill>
-                <a:latin typeface="JetBrains Mono"/>
-                <a:ea typeface="JetBrains Mono"/>
-                <a:cs typeface="JetBrains Mono"/>
-                <a:sym typeface="JetBrains Mono"/>
-              </a:rPr>
-              <a:t>MEMBER 02</a:t>
-            </a:r>
-            <a:endParaRPr/>
-          </a:p>
-        </p:txBody>
-      </p:sp>
-      <p:sp>
-        <p:nvSpPr>
-          <p:cNvPr id="312" name="Google Shape;312;p21"/>
-          <p:cNvSpPr txBox="1"/>
-          <p:nvPr/>
-        </p:nvSpPr>
-        <p:spPr>
-          <a:xfrm>
-            <a:off x="4609984" y="3174920"/>
-            <a:ext cx="2984425" cy="444488"/>
-          </a:xfrm>
-          <a:prstGeom prst="rect">
-            <a:avLst/>
-          </a:prstGeom>
-          <a:noFill/>
-          <a:ln>
-            <a:noFill/>
-          </a:ln>
-        </p:spPr>
-        <p:txBody>
-          <a:bodyPr anchorCtr="0" anchor="t" bIns="0" lIns="0" spcFirstLastPara="1" rIns="0" wrap="square" tIns="0">
-            <a:spAutoFit/>
-          </a:bodyPr>
-          <a:lstStyle/>
-          <a:p>
-            <a:pPr indent="0" lvl="0" marL="0" marR="0" rtl="0" algn="l">
-              <a:spcBef>
-                <a:spcPts val="0"/>
-              </a:spcBef>
-              <a:spcAft>
-                <a:spcPts val="0"/>
-              </a:spcAft>
-              <a:buNone/>
-              <a:defRPr sz="1700" b="1">
-                <a:solidFill>
-                  <a:srgbClr val="FFD778"/>
-                </a:solidFill>
-              </a:defRPr>
-            </a:pPr>
-            <a:r>
-              <a:rPr sz="1700" b="1">
-                <a:solidFill>
-                  <a:srgbClr val="FFD778"/>
-                </a:solidFill>
-              </a:rPr>
-              <a:t>AI Decision Agent</a:t>
-            </a:r>
-            <a:endParaRPr/>
-          </a:p>
-        </p:txBody>
-      </p:sp>
-      <p:sp>
-        <p:nvSpPr>
-          <p:cNvPr id="313" name="Google Shape;313;p21"/>
-          <p:cNvSpPr txBox="1"/>
-          <p:nvPr/>
-        </p:nvSpPr>
-        <p:spPr>
-          <a:xfrm>
-            <a:off x="4609984" y="3873403"/>
-            <a:ext cx="1015974" cy="253993"/>
-          </a:xfrm>
-          <a:prstGeom prst="rect">
-            <a:avLst/>
-          </a:prstGeom>
-          <a:noFill/>
-          <a:ln>
-            <a:noFill/>
-          </a:ln>
-        </p:spPr>
-        <p:txBody>
-          <a:bodyPr anchorCtr="0" anchor="t" bIns="0" lIns="0" spcFirstLastPara="1" rIns="0" wrap="square" tIns="0">
-            <a:spAutoFit/>
-          </a:bodyPr>
-          <a:lstStyle/>
-          <a:p>
-            <a:pPr indent="0" lvl="0" marL="0" marR="0" rtl="0" algn="l">
-              <a:spcBef>
-                <a:spcPts val="0"/>
-              </a:spcBef>
-              <a:spcAft>
-                <a:spcPts val="0"/>
-              </a:spcAft>
-              <a:buNone/>
-              <a:defRPr>
-                <a:solidFill/>
-              </a:defRPr>
-            </a:pPr>
-            <a:r>
-              <a:rPr b="1" i="0" lang="en-US" sz="850">
-                <a:solidFill>
-                  <a:srgbClr val="F5B937"/>
-                </a:solidFill>
-                <a:latin typeface="JetBrains Mono"/>
-                <a:ea typeface="JetBrains Mono"/>
-                <a:cs typeface="JetBrains Mono"/>
-                <a:sym typeface="JetBrains Mono"/>
-              </a:rPr>
-              <a:t>COLLEGE</a:t>
-            </a:r>
-            <a:endParaRPr/>
-          </a:p>
-        </p:txBody>
-      </p:sp>
-      <p:sp>
-        <p:nvSpPr>
-          <p:cNvPr id="314" name="Google Shape;314;p21"/>
-          <p:cNvSpPr txBox="1"/>
-          <p:nvPr/>
-        </p:nvSpPr>
-        <p:spPr>
-          <a:xfrm>
-            <a:off x="5651358" y="3848003"/>
-            <a:ext cx="1968450" cy="380990"/>
-          </a:xfrm>
-          <a:prstGeom prst="rect">
-            <a:avLst/>
-          </a:prstGeom>
-          <a:noFill/>
-          <a:ln>
-            <a:noFill/>
-          </a:ln>
-        </p:spPr>
-        <p:txBody>
-          <a:bodyPr anchorCtr="0" anchor="t" bIns="0" lIns="0" spcFirstLastPara="1" rIns="0" wrap="square" tIns="0">
-            <a:spAutoFit/>
-          </a:bodyPr>
-          <a:lstStyle/>
-          <a:p>
-            <a:pPr indent="0" lvl="0" marL="0" marR="0" rtl="0" algn="l">
-              <a:spcBef>
-                <a:spcPts val="0"/>
-              </a:spcBef>
-              <a:spcAft>
-                <a:spcPts val="0"/>
-              </a:spcAft>
-              <a:buNone/>
-              <a:defRPr sz="1200">
-                <a:solidFill>
-                  <a:srgbClr val="F8FAFC"/>
                 </a:solidFill>
               </a:defRPr>
             </a:pPr>
             <a:r>
               <a:rPr sz="1200">
                 <a:solidFill>
-                  <a:srgbClr val="F8FAFC"/>
+                  <a:srgbClr val="FFD778"/>
                 </a:solidFill>
               </a:rPr>
-              <a:t>TenderPulse Core</a:t>
-            </a:r>
-            <a:endParaRPr/>
-          </a:p>
-        </p:txBody>
-      </p:sp>
-      <p:sp>
-        <p:nvSpPr>
-          <p:cNvPr id="315" name="Google Shape;315;p21"/>
-          <p:cNvSpPr txBox="1"/>
-          <p:nvPr/>
-        </p:nvSpPr>
-        <p:spPr>
-          <a:xfrm>
-            <a:off x="4609984" y="4330591"/>
-            <a:ext cx="1015974" cy="253993"/>
-          </a:xfrm>
-          <a:prstGeom prst="rect">
-            <a:avLst/>
-          </a:prstGeom>
-          <a:noFill/>
-          <a:ln>
-            <a:noFill/>
-          </a:ln>
-        </p:spPr>
-        <p:txBody>
-          <a:bodyPr anchorCtr="0" anchor="t" bIns="0" lIns="0" spcFirstLastPara="1" rIns="0" wrap="square" tIns="0">
-            <a:spAutoFit/>
-          </a:bodyPr>
-          <a:lstStyle/>
-          <a:p>
-            <a:pPr indent="0" lvl="0" marL="0" marR="0" rtl="0" algn="l">
-              <a:spcBef>
-                <a:spcPts val="0"/>
-              </a:spcBef>
-              <a:spcAft>
-                <a:spcPts val="0"/>
-              </a:spcAft>
-              <a:buNone/>
-              <a:defRPr>
-                <a:solidFill/>
-              </a:defRPr>
-            </a:pPr>
-            <a:r>
-              <a:rPr b="1" i="0" lang="en-US" sz="850">
-                <a:solidFill>
-                  <a:srgbClr val="F5B937"/>
-                </a:solidFill>
-                <a:latin typeface="JetBrains Mono"/>
-                <a:ea typeface="JetBrains Mono"/>
-                <a:cs typeface="JetBrains Mono"/>
-                <a:sym typeface="JetBrains Mono"/>
-              </a:rPr>
-              <a:t>YEAR</a:t>
-            </a:r>
-            <a:endParaRPr/>
-          </a:p>
-        </p:txBody>
-      </p:sp>
-      <p:sp>
-        <p:nvSpPr>
-          <p:cNvPr id="316" name="Google Shape;316;p21"/>
-          <p:cNvSpPr txBox="1"/>
-          <p:nvPr/>
-        </p:nvSpPr>
-        <p:spPr>
-          <a:xfrm>
-            <a:off x="5651358" y="4305192"/>
-            <a:ext cx="1968450" cy="380990"/>
-          </a:xfrm>
-          <a:prstGeom prst="rect">
-            <a:avLst/>
-          </a:prstGeom>
-          <a:noFill/>
-          <a:ln>
-            <a:noFill/>
-          </a:ln>
-        </p:spPr>
-        <p:txBody>
-          <a:bodyPr anchorCtr="0" anchor="t" bIns="0" lIns="0" spcFirstLastPara="1" rIns="0" wrap="square" tIns="0">
-            <a:spAutoFit/>
-          </a:bodyPr>
-          <a:lstStyle/>
-          <a:p>
-            <a:pPr indent="0" lvl="0" marL="0" marR="0" rtl="0" algn="l">
-              <a:spcBef>
-                <a:spcPts val="0"/>
-              </a:spcBef>
-              <a:spcAft>
-                <a:spcPts val="0"/>
-              </a:spcAft>
-              <a:buNone/>
-              <a:defRPr sz="1200">
-                <a:solidFill>
-                  <a:srgbClr val="F8FAFC"/>
-                </a:solidFill>
-              </a:defRPr>
-            </a:pPr>
-            <a:r>
-              <a:rPr sz="1200">
-                <a:solidFill>
-                  <a:srgbClr val="F8FAFC"/>
-                </a:solidFill>
-              </a:rPr>
-              <a:t>Production Layer</a:t>
-            </a:r>
-            <a:endParaRPr/>
-          </a:p>
-        </p:txBody>
-      </p:sp>
-      <p:sp>
-        <p:nvSpPr>
-          <p:cNvPr id="317" name="Google Shape;317;p21"/>
-          <p:cNvSpPr txBox="1"/>
-          <p:nvPr/>
-        </p:nvSpPr>
-        <p:spPr>
-          <a:xfrm>
-            <a:off x="4609984" y="4787780"/>
-            <a:ext cx="1015974" cy="253993"/>
-          </a:xfrm>
-          <a:prstGeom prst="rect">
-            <a:avLst/>
-          </a:prstGeom>
-          <a:noFill/>
-          <a:ln>
-            <a:noFill/>
-          </a:ln>
-        </p:spPr>
-        <p:txBody>
-          <a:bodyPr anchorCtr="0" anchor="t" bIns="0" lIns="0" spcFirstLastPara="1" rIns="0" wrap="square" tIns="0">
-            <a:spAutoFit/>
-          </a:bodyPr>
-          <a:lstStyle/>
-          <a:p>
-            <a:pPr indent="0" lvl="0" marL="0" marR="0" rtl="0" algn="l">
-              <a:spcBef>
-                <a:spcPts val="0"/>
-              </a:spcBef>
-              <a:spcAft>
-                <a:spcPts val="0"/>
-              </a:spcAft>
-              <a:buNone/>
-              <a:defRPr>
-                <a:solidFill/>
-              </a:defRPr>
-            </a:pPr>
-            <a:r>
-              <a:rPr b="1" i="0" lang="en-US" sz="850">
-                <a:solidFill>
-                  <a:srgbClr val="F5B937"/>
-                </a:solidFill>
-                <a:latin typeface="JetBrains Mono"/>
-                <a:ea typeface="JetBrains Mono"/>
-                <a:cs typeface="JetBrains Mono"/>
-                <a:sym typeface="JetBrains Mono"/>
-              </a:rPr>
-              <a:t>ROLE</a:t>
-            </a:r>
-            <a:endParaRPr/>
-          </a:p>
-        </p:txBody>
-      </p:sp>
-      <p:sp>
-        <p:nvSpPr>
-          <p:cNvPr id="318" name="Google Shape;318;p21"/>
-          <p:cNvSpPr txBox="1"/>
-          <p:nvPr/>
-        </p:nvSpPr>
-        <p:spPr>
-          <a:xfrm>
-            <a:off x="5651358" y="4762380"/>
-            <a:ext cx="1968450" cy="380990"/>
-          </a:xfrm>
-          <a:prstGeom prst="rect">
-            <a:avLst/>
-          </a:prstGeom>
-          <a:noFill/>
-          <a:ln>
-            <a:noFill/>
-          </a:ln>
-        </p:spPr>
-        <p:txBody>
-          <a:bodyPr anchorCtr="0" anchor="t" bIns="0" lIns="0" spcFirstLastPara="1" rIns="0" wrap="square" tIns="0">
-            <a:spAutoFit/>
-          </a:bodyPr>
-          <a:lstStyle/>
-          <a:p>
-            <a:pPr indent="0" lvl="0" marL="0" marR="0" rtl="0" algn="l">
-              <a:spcBef>
-                <a:spcPts val="0"/>
-              </a:spcBef>
-              <a:spcAft>
-                <a:spcPts val="0"/>
-              </a:spcAft>
-              <a:buNone/>
-              <a:defRPr sz="1100">
-                <a:solidFill>
-                  <a:srgbClr val="F8FAFC"/>
-                </a:solidFill>
-              </a:defRPr>
-            </a:pPr>
-            <a:r>
-              <a:rPr sz="1100">
-                <a:solidFill>
-                  <a:srgbClr val="F8FAFC"/>
-                </a:solidFill>
-              </a:rPr>
-              <a:t>Multi-Tool Rule Solvers &amp; Layout Ingestion</a:t>
-            </a:r>
-            <a:endParaRPr/>
-          </a:p>
-        </p:txBody>
-      </p:sp>
-      <p:sp>
-        <p:nvSpPr>
-          <p:cNvPr id="319" name="Google Shape;319;p21"/>
-          <p:cNvSpPr txBox="1"/>
-          <p:nvPr/>
-        </p:nvSpPr>
-        <p:spPr>
-          <a:xfrm>
-            <a:off x="4609984" y="5244968"/>
-            <a:ext cx="1015974" cy="253993"/>
-          </a:xfrm>
-          <a:prstGeom prst="rect">
-            <a:avLst/>
-          </a:prstGeom>
-          <a:noFill/>
-          <a:ln>
-            <a:noFill/>
-          </a:ln>
-        </p:spPr>
-        <p:txBody>
-          <a:bodyPr anchorCtr="0" anchor="t" bIns="0" lIns="0" spcFirstLastPara="1" rIns="0" wrap="square" tIns="0">
-            <a:spAutoFit/>
-          </a:bodyPr>
-          <a:lstStyle/>
-          <a:p>
-            <a:pPr indent="0" lvl="0" marL="0" marR="0" rtl="0" algn="l">
-              <a:spcBef>
-                <a:spcPts val="0"/>
-              </a:spcBef>
-              <a:spcAft>
-                <a:spcPts val="0"/>
-              </a:spcAft>
-              <a:buNone/>
-              <a:defRPr>
-                <a:solidFill/>
-              </a:defRPr>
-            </a:pPr>
-            <a:r>
-              <a:rPr b="1" i="0" lang="en-US" sz="850">
-                <a:solidFill>
-                  <a:srgbClr val="F5B937"/>
-                </a:solidFill>
-                <a:latin typeface="JetBrains Mono"/>
-                <a:ea typeface="JetBrains Mono"/>
-                <a:cs typeface="JetBrains Mono"/>
-                <a:sym typeface="JetBrains Mono"/>
-              </a:rPr>
-              <a:t>LINKEDIN</a:t>
-            </a:r>
-            <a:endParaRPr/>
-          </a:p>
-        </p:txBody>
-      </p:sp>
-      <p:sp>
-        <p:nvSpPr>
-          <p:cNvPr id="320" name="Google Shape;320;p21"/>
-          <p:cNvSpPr txBox="1"/>
-          <p:nvPr/>
-        </p:nvSpPr>
-        <p:spPr>
-          <a:xfrm>
-            <a:off x="5651358" y="5219569"/>
-            <a:ext cx="1968450" cy="380990"/>
-          </a:xfrm>
-          <a:prstGeom prst="rect">
-            <a:avLst/>
-          </a:prstGeom>
-          <a:noFill/>
-          <a:ln>
-            <a:noFill/>
-          </a:ln>
-        </p:spPr>
-        <p:txBody>
-          <a:bodyPr anchorCtr="0" anchor="t" bIns="0" lIns="0" spcFirstLastPara="1" rIns="0" wrap="square" tIns="0">
-            <a:spAutoFit/>
-          </a:bodyPr>
-          <a:lstStyle/>
-          <a:p>
-            <a:pPr indent="0" lvl="0" marL="0" marR="0" rtl="0" algn="l">
-              <a:spcBef>
-                <a:spcPts val="0"/>
-              </a:spcBef>
-              <a:spcAft>
-                <a:spcPts val="0"/>
-              </a:spcAft>
-              <a:buNone/>
-              <a:defRPr sz="1100">
-                <a:solidFill>
-                  <a:srgbClr val="FFD778"/>
-                </a:solidFill>
-              </a:defRPr>
-            </a:pPr>
-            <a:r>
-              <a:rPr sz="1100">
-                <a:solidFill>
-                  <a:srgbClr val="FFD778"/>
-                </a:solidFill>
-              </a:rPr>
-              <a:t>https://ai-build-hackathon.onrender.com</a:t>
-            </a:r>
-            <a:endParaRPr/>
-          </a:p>
-        </p:txBody>
-      </p:sp>
-      <p:sp>
-        <p:nvSpPr>
-          <p:cNvPr id="321" name="Google Shape;321;p21"/>
-          <p:cNvSpPr/>
-          <p:nvPr/>
-        </p:nvSpPr>
-        <p:spPr>
-          <a:xfrm>
-            <a:off x="8051598" y="2666933"/>
-            <a:ext cx="3428914" cy="3174920"/>
-          </a:xfrm>
-          <a:prstGeom prst="roundRect">
-            <a:avLst>
-              <a:gd fmla="val 6000" name="adj"/>
-            </a:avLst>
-          </a:prstGeom>
-          <a:solidFill>
-            <a:srgbClr val="17130E"/>
-          </a:solidFill>
-          <a:ln cap="flat" cmpd="sng" w="12700">
-            <a:solidFill>
-              <a:srgbClr val="332D25"/>
-            </a:solidFill>
-            <a:prstDash val="solid"/>
-            <a:round/>
-            <a:headEnd len="sm" w="sm" type="none"/>
-            <a:tailEnd len="sm" w="sm" type="none"/>
-          </a:ln>
-        </p:spPr>
-        <p:txBody>
-          <a:bodyPr anchorCtr="0" anchor="ctr" bIns="45700" lIns="91425" spcFirstLastPara="1" rIns="91425" wrap="square" tIns="45700">
-            <a:noAutofit/>
-          </a:bodyPr>
-          <a:lstStyle/>
-          <a:p>
-            <a:pPr indent="0" lvl="0" marL="0" marR="0" rtl="0" algn="l">
-              <a:spcBef>
-                <a:spcPts val="0"/>
-              </a:spcBef>
-              <a:spcAft>
-                <a:spcPts val="0"/>
-              </a:spcAft>
-              <a:buNone/>
-            </a:pPr>
-            <a:r>
-              <a:t/>
-            </a:r>
-            <a:endParaRPr sz="1800">
-              <a:solidFill>
-                <a:schemeClr val="dk1"/>
-              </a:solidFill>
-              <a:latin typeface="Calibri"/>
-              <a:ea typeface="Calibri"/>
-              <a:cs typeface="Calibri"/>
-              <a:sym typeface="Calibri"/>
-            </a:endParaRPr>
-          </a:p>
-        </p:txBody>
-      </p:sp>
-      <p:sp>
-        <p:nvSpPr>
-          <p:cNvPr id="322" name="Google Shape;322;p21"/>
-          <p:cNvSpPr txBox="1"/>
-          <p:nvPr/>
-        </p:nvSpPr>
-        <p:spPr>
-          <a:xfrm>
-            <a:off x="8280192" y="2870128"/>
-            <a:ext cx="2984425" cy="190495"/>
-          </a:xfrm>
-          <a:prstGeom prst="rect">
-            <a:avLst/>
-          </a:prstGeom>
-          <a:noFill/>
-          <a:ln>
-            <a:noFill/>
-          </a:ln>
-        </p:spPr>
-        <p:txBody>
-          <a:bodyPr anchorCtr="0" anchor="t" bIns="0" lIns="0" spcFirstLastPara="1" rIns="0" wrap="square" tIns="0">
-            <a:spAutoFit/>
-          </a:bodyPr>
-          <a:lstStyle/>
-          <a:p>
-            <a:pPr indent="0" lvl="0" marL="0" marR="0" rtl="0" algn="l">
-              <a:spcBef>
-                <a:spcPts val="0"/>
-              </a:spcBef>
-              <a:spcAft>
-                <a:spcPts val="0"/>
-              </a:spcAft>
-              <a:buNone/>
-              <a:defRPr>
-                <a:solidFill/>
-              </a:defRPr>
-            </a:pPr>
-            <a:r>
-              <a:rPr b="1" i="0" lang="en-US" sz="950">
-                <a:solidFill>
-                  <a:srgbClr val="F2B632"/>
-                </a:solidFill>
-                <a:latin typeface="JetBrains Mono"/>
-                <a:ea typeface="JetBrains Mono"/>
-                <a:cs typeface="JetBrains Mono"/>
-                <a:sym typeface="JetBrains Mono"/>
-              </a:rPr>
-              <a:t>MEMBER 03</a:t>
-            </a:r>
-            <a:endParaRPr/>
-          </a:p>
-        </p:txBody>
-      </p:sp>
-      <p:sp>
-        <p:nvSpPr>
-          <p:cNvPr id="323" name="Google Shape;323;p21"/>
-          <p:cNvSpPr txBox="1"/>
-          <p:nvPr/>
-        </p:nvSpPr>
-        <p:spPr>
-          <a:xfrm>
-            <a:off x="8280192" y="3174920"/>
-            <a:ext cx="2984425" cy="444488"/>
-          </a:xfrm>
-          <a:prstGeom prst="rect">
-            <a:avLst/>
-          </a:prstGeom>
-          <a:noFill/>
-          <a:ln>
-            <a:noFill/>
-          </a:ln>
-        </p:spPr>
-        <p:txBody>
-          <a:bodyPr anchorCtr="0" anchor="t" bIns="0" lIns="0" spcFirstLastPara="1" rIns="0" wrap="square" tIns="0">
-            <a:spAutoFit/>
-          </a:bodyPr>
-          <a:lstStyle/>
-          <a:p>
-            <a:pPr indent="0" lvl="0" marL="0" marR="0" rtl="0" algn="l">
-              <a:spcBef>
-                <a:spcPts val="0"/>
-              </a:spcBef>
-              <a:spcAft>
-                <a:spcPts val="0"/>
-              </a:spcAft>
-              <a:buNone/>
-              <a:defRPr sz="1700" b="1">
-                <a:solidFill>
-                  <a:srgbClr val="FFD778"/>
-                </a:solidFill>
-              </a:defRPr>
-            </a:pPr>
-            <a:r>
-              <a:rPr sz="1700" b="1">
-                <a:solidFill>
-                  <a:srgbClr val="FFD778"/>
-                </a:solidFill>
-              </a:rPr>
-              <a:t>Audit Reflection Guardrail</a:t>
-            </a:r>
-            <a:endParaRPr/>
-          </a:p>
-        </p:txBody>
-      </p:sp>
-      <p:sp>
-        <p:nvSpPr>
-          <p:cNvPr id="324" name="Google Shape;324;p21"/>
-          <p:cNvSpPr txBox="1"/>
-          <p:nvPr/>
-        </p:nvSpPr>
-        <p:spPr>
-          <a:xfrm>
-            <a:off x="8280192" y="3873403"/>
-            <a:ext cx="1015974" cy="253993"/>
-          </a:xfrm>
-          <a:prstGeom prst="rect">
-            <a:avLst/>
-          </a:prstGeom>
-          <a:noFill/>
-          <a:ln>
-            <a:noFill/>
-          </a:ln>
-        </p:spPr>
-        <p:txBody>
-          <a:bodyPr anchorCtr="0" anchor="t" bIns="0" lIns="0" spcFirstLastPara="1" rIns="0" wrap="square" tIns="0">
-            <a:spAutoFit/>
-          </a:bodyPr>
-          <a:lstStyle/>
-          <a:p>
-            <a:pPr indent="0" lvl="0" marL="0" marR="0" rtl="0" algn="l">
-              <a:spcBef>
-                <a:spcPts val="0"/>
-              </a:spcBef>
-              <a:spcAft>
-                <a:spcPts val="0"/>
-              </a:spcAft>
-              <a:buNone/>
-              <a:defRPr>
-                <a:solidFill/>
-              </a:defRPr>
-            </a:pPr>
-            <a:r>
-              <a:rPr b="1" i="0" lang="en-US" sz="850">
-                <a:solidFill>
-                  <a:srgbClr val="F5B937"/>
-                </a:solidFill>
-                <a:latin typeface="JetBrains Mono"/>
-                <a:ea typeface="JetBrains Mono"/>
-                <a:cs typeface="JetBrains Mono"/>
-                <a:sym typeface="JetBrains Mono"/>
-              </a:rPr>
-              <a:t>COLLEGE</a:t>
-            </a:r>
-            <a:endParaRPr/>
-          </a:p>
-        </p:txBody>
-      </p:sp>
-      <p:sp>
-        <p:nvSpPr>
-          <p:cNvPr id="325" name="Google Shape;325;p21"/>
-          <p:cNvSpPr txBox="1"/>
-          <p:nvPr/>
-        </p:nvSpPr>
-        <p:spPr>
-          <a:xfrm>
-            <a:off x="9321566" y="3848003"/>
-            <a:ext cx="1968450" cy="380990"/>
-          </a:xfrm>
-          <a:prstGeom prst="rect">
-            <a:avLst/>
-          </a:prstGeom>
-          <a:noFill/>
-          <a:ln>
-            <a:noFill/>
-          </a:ln>
-        </p:spPr>
-        <p:txBody>
-          <a:bodyPr anchorCtr="0" anchor="t" bIns="0" lIns="0" spcFirstLastPara="1" rIns="0" wrap="square" tIns="0">
-            <a:spAutoFit/>
-          </a:bodyPr>
-          <a:lstStyle/>
-          <a:p>
-            <a:pPr indent="0" lvl="0" marL="0" marR="0" rtl="0" algn="l">
-              <a:spcBef>
-                <a:spcPts val="0"/>
-              </a:spcBef>
-              <a:spcAft>
-                <a:spcPts val="0"/>
-              </a:spcAft>
-              <a:buNone/>
-              <a:defRPr sz="1200">
-                <a:solidFill>
-                  <a:srgbClr val="F8FAFC"/>
-                </a:solidFill>
-              </a:defRPr>
-            </a:pPr>
-            <a:r>
-              <a:rPr sz="1200">
-                <a:solidFill>
-                  <a:srgbClr val="F8FAFC"/>
-                </a:solidFill>
-              </a:rPr>
-              <a:t>CVC Compliance Engine</a:t>
-            </a:r>
-            <a:endParaRPr/>
-          </a:p>
-        </p:txBody>
-      </p:sp>
-      <p:sp>
-        <p:nvSpPr>
-          <p:cNvPr id="326" name="Google Shape;326;p21"/>
-          <p:cNvSpPr txBox="1"/>
-          <p:nvPr/>
-        </p:nvSpPr>
-        <p:spPr>
-          <a:xfrm>
-            <a:off x="8280192" y="4330591"/>
-            <a:ext cx="1015974" cy="253993"/>
-          </a:xfrm>
-          <a:prstGeom prst="rect">
-            <a:avLst/>
-          </a:prstGeom>
-          <a:noFill/>
-          <a:ln>
-            <a:noFill/>
-          </a:ln>
-        </p:spPr>
-        <p:txBody>
-          <a:bodyPr anchorCtr="0" anchor="t" bIns="0" lIns="0" spcFirstLastPara="1" rIns="0" wrap="square" tIns="0">
-            <a:spAutoFit/>
-          </a:bodyPr>
-          <a:lstStyle/>
-          <a:p>
-            <a:pPr indent="0" lvl="0" marL="0" marR="0" rtl="0" algn="l">
-              <a:spcBef>
-                <a:spcPts val="0"/>
-              </a:spcBef>
-              <a:spcAft>
-                <a:spcPts val="0"/>
-              </a:spcAft>
-              <a:buNone/>
-              <a:defRPr>
-                <a:solidFill/>
-              </a:defRPr>
-            </a:pPr>
-            <a:r>
-              <a:rPr b="1" i="0" lang="en-US" sz="850">
-                <a:solidFill>
-                  <a:srgbClr val="F5B937"/>
-                </a:solidFill>
-                <a:latin typeface="JetBrains Mono"/>
-                <a:ea typeface="JetBrains Mono"/>
-                <a:cs typeface="JetBrains Mono"/>
-                <a:sym typeface="JetBrains Mono"/>
-              </a:rPr>
-              <a:t>YEAR</a:t>
-            </a:r>
-            <a:endParaRPr/>
-          </a:p>
-        </p:txBody>
-      </p:sp>
-      <p:sp>
-        <p:nvSpPr>
-          <p:cNvPr id="327" name="Google Shape;327;p21"/>
-          <p:cNvSpPr txBox="1"/>
-          <p:nvPr/>
-        </p:nvSpPr>
-        <p:spPr>
-          <a:xfrm>
-            <a:off x="9321566" y="4305192"/>
-            <a:ext cx="1968450" cy="380990"/>
-          </a:xfrm>
-          <a:prstGeom prst="rect">
-            <a:avLst/>
-          </a:prstGeom>
-          <a:noFill/>
-          <a:ln>
-            <a:noFill/>
-          </a:ln>
-        </p:spPr>
-        <p:txBody>
-          <a:bodyPr anchorCtr="0" anchor="t" bIns="0" lIns="0" spcFirstLastPara="1" rIns="0" wrap="square" tIns="0">
-            <a:spAutoFit/>
-          </a:bodyPr>
-          <a:lstStyle/>
-          <a:p>
-            <a:pPr indent="0" lvl="0" marL="0" marR="0" rtl="0" algn="l">
-              <a:spcBef>
-                <a:spcPts val="0"/>
-              </a:spcBef>
-              <a:spcAft>
-                <a:spcPts val="0"/>
-              </a:spcAft>
-              <a:buNone/>
-              <a:defRPr sz="1200">
-                <a:solidFill>
-                  <a:srgbClr val="F8FAFC"/>
-                </a:solidFill>
-              </a:defRPr>
-            </a:pPr>
-            <a:r>
-              <a:rPr sz="1200">
-                <a:solidFill>
-                  <a:srgbClr val="F8FAFC"/>
-                </a:solidFill>
-              </a:rPr>
-              <a:t>Verification Layer</a:t>
-            </a:r>
-            <a:endParaRPr/>
-          </a:p>
-        </p:txBody>
-      </p:sp>
-      <p:sp>
-        <p:nvSpPr>
-          <p:cNvPr id="328" name="Google Shape;328;p21"/>
-          <p:cNvSpPr txBox="1"/>
-          <p:nvPr/>
-        </p:nvSpPr>
-        <p:spPr>
-          <a:xfrm>
-            <a:off x="8280192" y="4787780"/>
-            <a:ext cx="1015974" cy="253993"/>
-          </a:xfrm>
-          <a:prstGeom prst="rect">
-            <a:avLst/>
-          </a:prstGeom>
-          <a:noFill/>
-          <a:ln>
-            <a:noFill/>
-          </a:ln>
-        </p:spPr>
-        <p:txBody>
-          <a:bodyPr anchorCtr="0" anchor="t" bIns="0" lIns="0" spcFirstLastPara="1" rIns="0" wrap="square" tIns="0">
-            <a:spAutoFit/>
-          </a:bodyPr>
-          <a:lstStyle/>
-          <a:p>
-            <a:pPr indent="0" lvl="0" marL="0" marR="0" rtl="0" algn="l">
-              <a:spcBef>
-                <a:spcPts val="0"/>
-              </a:spcBef>
-              <a:spcAft>
-                <a:spcPts val="0"/>
-              </a:spcAft>
-              <a:buNone/>
-              <a:defRPr>
-                <a:solidFill/>
-              </a:defRPr>
-            </a:pPr>
-            <a:r>
-              <a:rPr b="1" i="0" lang="en-US" sz="850">
-                <a:solidFill>
-                  <a:srgbClr val="F5B937"/>
-                </a:solidFill>
-                <a:latin typeface="JetBrains Mono"/>
-                <a:ea typeface="JetBrains Mono"/>
-                <a:cs typeface="JetBrains Mono"/>
-                <a:sym typeface="JetBrains Mono"/>
-              </a:rPr>
-              <a:t>ROLE</a:t>
-            </a:r>
-            <a:endParaRPr/>
-          </a:p>
-        </p:txBody>
-      </p:sp>
-      <p:sp>
-        <p:nvSpPr>
-          <p:cNvPr id="329" name="Google Shape;329;p21"/>
-          <p:cNvSpPr txBox="1"/>
-          <p:nvPr/>
-        </p:nvSpPr>
-        <p:spPr>
-          <a:xfrm>
-            <a:off x="9321566" y="4762380"/>
-            <a:ext cx="1968450" cy="380990"/>
-          </a:xfrm>
-          <a:prstGeom prst="rect">
-            <a:avLst/>
-          </a:prstGeom>
-          <a:noFill/>
-          <a:ln>
-            <a:noFill/>
-          </a:ln>
-        </p:spPr>
-        <p:txBody>
-          <a:bodyPr anchorCtr="0" anchor="t" bIns="0" lIns="0" spcFirstLastPara="1" rIns="0" wrap="square" tIns="0">
-            <a:spAutoFit/>
-          </a:bodyPr>
-          <a:lstStyle/>
-          <a:p>
-            <a:pPr indent="0" lvl="0" marL="0" marR="0" rtl="0" algn="l">
-              <a:spcBef>
-                <a:spcPts val="0"/>
-              </a:spcBef>
-              <a:spcAft>
-                <a:spcPts val="0"/>
-              </a:spcAft>
-              <a:buNone/>
-              <a:defRPr sz="1100">
-                <a:solidFill>
-                  <a:srgbClr val="F8FAFC"/>
-                </a:solidFill>
-              </a:defRPr>
-            </a:pPr>
-            <a:r>
-              <a:rPr sz="1100">
-                <a:solidFill>
-                  <a:srgbClr val="F8FAFC"/>
-                </a:solidFill>
-              </a:rPr>
-              <a:t>Self-Correction &amp; Trajectory Logging</a:t>
-            </a:r>
-            <a:endParaRPr/>
-          </a:p>
-        </p:txBody>
-      </p:sp>
-      <p:sp>
-        <p:nvSpPr>
-          <p:cNvPr id="330" name="Google Shape;330;p21"/>
-          <p:cNvSpPr txBox="1"/>
-          <p:nvPr/>
-        </p:nvSpPr>
-        <p:spPr>
-          <a:xfrm>
-            <a:off x="8280192" y="5244968"/>
-            <a:ext cx="1015974" cy="253993"/>
-          </a:xfrm>
-          <a:prstGeom prst="rect">
-            <a:avLst/>
-          </a:prstGeom>
-          <a:noFill/>
-          <a:ln>
-            <a:noFill/>
-          </a:ln>
-        </p:spPr>
-        <p:txBody>
-          <a:bodyPr anchorCtr="0" anchor="t" bIns="0" lIns="0" spcFirstLastPara="1" rIns="0" wrap="square" tIns="0">
-            <a:spAutoFit/>
-          </a:bodyPr>
-          <a:lstStyle/>
-          <a:p>
-            <a:pPr indent="0" lvl="0" marL="0" marR="0" rtl="0" algn="l">
-              <a:spcBef>
-                <a:spcPts val="0"/>
-              </a:spcBef>
-              <a:spcAft>
-                <a:spcPts val="0"/>
-              </a:spcAft>
-              <a:buNone/>
-              <a:defRPr>
-                <a:solidFill/>
-              </a:defRPr>
-            </a:pPr>
-            <a:r>
-              <a:rPr b="1" i="0" lang="en-US" sz="850">
-                <a:solidFill>
-                  <a:srgbClr val="F5B937"/>
-                </a:solidFill>
-                <a:latin typeface="JetBrains Mono"/>
-                <a:ea typeface="JetBrains Mono"/>
-                <a:cs typeface="JetBrains Mono"/>
-                <a:sym typeface="JetBrains Mono"/>
-              </a:rPr>
-              <a:t>LINKEDIN</a:t>
-            </a:r>
-            <a:endParaRPr/>
-          </a:p>
-        </p:txBody>
-      </p:sp>
-      <p:sp>
-        <p:nvSpPr>
-          <p:cNvPr id="331" name="Google Shape;331;p21"/>
-          <p:cNvSpPr txBox="1"/>
-          <p:nvPr/>
-        </p:nvSpPr>
-        <p:spPr>
-          <a:xfrm>
-            <a:off x="9321566" y="5219569"/>
-            <a:ext cx="1968450" cy="380990"/>
-          </a:xfrm>
-          <a:prstGeom prst="rect">
-            <a:avLst/>
-          </a:prstGeom>
-          <a:noFill/>
-          <a:ln>
-            <a:noFill/>
-          </a:ln>
-        </p:spPr>
-        <p:txBody>
-          <a:bodyPr anchorCtr="0" anchor="t" bIns="0" lIns="0" spcFirstLastPara="1" rIns="0" wrap="square" tIns="0">
-            <a:spAutoFit/>
-          </a:bodyPr>
-          <a:lstStyle/>
-          <a:p>
-            <a:pPr indent="0" lvl="0" marL="0" marR="0" rtl="0" algn="l">
-              <a:spcBef>
-                <a:spcPts val="0"/>
-              </a:spcBef>
-              <a:spcAft>
-                <a:spcPts val="0"/>
-              </a:spcAft>
-              <a:buNone/>
-              <a:defRPr sz="1100">
-                <a:solidFill>
-                  <a:srgbClr val="FFD778"/>
-                </a:solidFill>
-              </a:defRPr>
-            </a:pPr>
-            <a:r>
-              <a:rPr sz="1100">
-                <a:solidFill>
-                  <a:srgbClr val="FFD778"/>
-                </a:solidFill>
-              </a:rPr>
-              <a:t>https://ai-build-hackathon.onrender.com</a:t>
+              <a:t>https://github.com/darshan-s-44</a:t>
             </a:r>
             <a:endParaRPr/>
           </a:p>

</xml_diff>